<commit_message>
Final güncelleme: rapor %31.0/%69.0 düzeltmesi, sunum RF/GB karşılaştırması, son görseller
</commit_message>
<xml_diff>
--- a/sunum.pptx
+++ b/sunum.pptx
@@ -2713,7 +2713,7 @@
                 <a:ea typeface="Aptos Display"/>
                 <a:cs typeface="Aptos Display"/>
               </a:rPr>
-              <a:t>111116</a:t>
+              <a:t>1776</a:t>
             </a:r>
           </a:p>
         </p:txBody>
@@ -2926,7 +2926,7 @@
                 <a:ea typeface="Aptos Display"/>
                 <a:cs typeface="Aptos Display"/>
               </a:rPr>
-              <a:t>551 / 12145</a:t>
+              <a:t>551 / 1225</a:t>
             </a:r>
           </a:p>
         </p:txBody>
@@ -3251,7 +3251,7 @@
                 <a:ea typeface="Aptos"/>
                 <a:cs typeface="Aptos"/>
               </a:rPr>
-              <a:t>RF: F1=0.114214 · AUC=0.11824</a:t>
+              <a:t>RF: F1=0.7429 · AUC=0.7824</a:t>
             </a:r>
           </a:p>
         </p:txBody>
@@ -3307,7 +3307,7 @@
                 <a:ea typeface="Aptos"/>
                 <a:cs typeface="Aptos"/>
               </a:rPr>
-              <a:t>Betül Arslan  ·  Turkish-Gemma-14B-T1  ·  ytu-ce-cosmos/gsm8k_tr</a:t>
+              <a:t>Betül Arslan  ·  Turkish-Gemma-9B-T1  ·  ytu-ce-cosmos/gsm8k_tr</a:t>
             </a:r>
           </a:p>
         </p:txBody>
@@ -3717,7 +3717,7 @@
                 <a:ea typeface="Aptos"/>
                 <a:cs typeface="Aptos"/>
               </a:rPr>
-              <a:t>• 111116 koşusu ödevin tam dengeli hedefi için yeterli doğru sınıf üretmedi.</a:t>
+              <a:t>• 1776 koşusu ödevin tam dengeli hedefi için yeterli doğru sınıf üretmedi.</a:t>
             </a:r>
           </a:p>
           <a:p xmlns:a="http://schemas.openxmlformats.org/drawingml/2006/main">
@@ -3943,7 +3943,7 @@
                 <a:ea typeface="Aptos"/>
                 <a:cs typeface="Aptos"/>
               </a:rPr>
-              <a:t>• Checkpointten devam: N_RUN 11150 → gerekirse 1820/1600.</a:t>
+              <a:t>• Checkpointten devam: N_RUN 1750 → gerekirse 1820/1900.</a:t>
             </a:r>
           </a:p>
           <a:p xmlns:a="http://schemas.openxmlformats.org/drawingml/2006/main">
@@ -4068,7 +4068,7 @@
                 <a:ea typeface="Aptos"/>
                 <a:cs typeface="Aptos"/>
               </a:rPr>
-              <a:t>Top1-top2 farkı, ek kaynak gerektirmeden modelin iç sinyalinden güven tahmini yapılabildiğini gösterdi.</a:t>
+              <a:t>Top1-top2 farkı, modelin iç sinyalinden güven tahmini yapılabildiğini gösterdi.</a:t>
             </a:r>
           </a:p>
         </p:txBody>
@@ -4478,7 +4478,7 @@
                 <a:ea typeface="Aptos"/>
                 <a:cs typeface="Aptos"/>
               </a:rPr>
-              <a:t>Final ölçekte RF lider (F1)</a:t>
+              <a:t>F1'de RF lider</a:t>
             </a:r>
           </a:p>
         </p:txBody>
@@ -4534,7 +4534,7 @@
                 <a:ea typeface="Aptos"/>
                 <a:cs typeface="Aptos"/>
               </a:rPr>
-              <a:t>F1=0.1161114 ve AUC=0.8032 ile en iyi model.</a:t>
+              <a:t>F1=0.7429, Acc=0.73 — F1/Accuracy lideri.</a:t>
             </a:r>
           </a:p>
         </p:txBody>
@@ -4904,7 +4904,7 @@
                 <a:ea typeface="Aptos"/>
                 <a:cs typeface="Aptos"/>
               </a:rPr>
-              <a:t>GB en yüksek AUC</a:t>
+              <a:t>AUC'de GB lider</a:t>
             </a:r>
           </a:p>
         </p:txBody>
@@ -4960,7 +4960,7 @@
                 <a:ea typeface="Aptos"/>
                 <a:cs typeface="Aptos"/>
               </a:rPr>
-              <a:t>551 doğru var; hedef 550 doğruya ulaşmak.</a:t>
+              <a:t>AUC=0.7936 — eşik bağımsız ayırt etmede öne çıktı.</a:t>
             </a:r>
           </a:p>
         </p:txBody>
@@ -5016,7 +5016,7 @@
                 <a:ea typeface="Aptos"/>
                 <a:cs typeface="Aptos"/>
               </a:rPr>
-              <a:t>Top1-top2 farkı, ek dış bilgi gerektirmeksizin modelin üretim sürecinden elde edilebilen güvenilir bir kalite göstergesidir.</a:t>
+              <a:t>Top1-top2 farkı ek dış bilgi gerektirmeksizin modelin üretim sürecinden güvenilir kalite göstergesi olarak elde edilebilir.</a:t>
             </a:r>
           </a:p>
         </p:txBody>
@@ -5072,7 +5072,7 @@
                 <a:ea typeface="Aptos"/>
                 <a:cs typeface="Aptos"/>
               </a:rPr>
-              <a:t>12</a:t>
+              <a:t>11</a:t>
             </a:r>
           </a:p>
         </p:txBody>
@@ -8707,7 +8707,7 @@
                 <a:ea typeface="Aptos"/>
                 <a:cs typeface="Aptos"/>
               </a:rPr>
-              <a:t>q115</a:t>
+              <a:t>q75</a:t>
             </a:r>
           </a:p>
         </p:txBody>
@@ -9768,7 +9768,7 @@
                 <a:ea typeface="Aptos"/>
                 <a:cs typeface="Aptos"/>
               </a:rPr>
-              <a:t>111116 soru üretildi. 551 doğru, 12145 yanlış. Dengeli set oluşturuldu.</a:t>
+              <a:t>1776 soru üretildi. 551 doğru, 1225 yanlış. Dengeli set oluşturuldu.</a:t>
             </a:r>
           </a:p>
         </p:txBody>
@@ -9869,7 +9869,7 @@
                 <a:ea typeface="Aptos Display"/>
                 <a:cs typeface="Aptos Display"/>
               </a:rPr>
-              <a:t>111116</a:t>
+              <a:t>1776</a:t>
             </a:r>
           </a:p>
         </p:txBody>
@@ -10295,7 +10295,7 @@
                 <a:ea typeface="Aptos Display"/>
                 <a:cs typeface="Aptos Display"/>
               </a:rPr>
-              <a:t>12145</a:t>
+              <a:t>1225</a:t>
             </a:r>
           </a:p>
         </p:txBody>
@@ -11292,7 +11292,7 @@
                 <a:ea typeface="Aptos"/>
                 <a:cs typeface="Aptos"/>
               </a:rPr>
-              <a:t>• Gereken toplam: 550 doğru + 550 yanlış</a:t>
+              <a:t>• Hedef aşıldı: 551 doğru + 1225 yanlış</a:t>
             </a:r>
           </a:p>
           <a:p xmlns:a="http://schemas.openxmlformats.org/drawingml/2006/main">
@@ -11315,7 +11315,7 @@
                 <a:ea typeface="Aptos"/>
                 <a:cs typeface="Aptos"/>
               </a:rPr>
-              <a:t>• Sonraki koşu: N_RUN 11150/1820 aralığına çıkarılacak</a:t>
+              <a:t>• Sonraki koşu: N_RUN 1750/1820 aralığına çıkarılacak</a:t>
             </a:r>
           </a:p>
         </p:txBody>
@@ -11512,7 +11512,7 @@
                 <a:ea typeface="Aptos Display"/>
                 <a:cs typeface="Aptos Display"/>
               </a:rPr>
-              <a:t>Final ölçekte en güçlü model Random Forest</a:t>
+              <a:t>Final sonuçlar: RF ve GB karşılaştırması</a:t>
             </a:r>
           </a:p>
         </p:txBody>
@@ -11568,7 +11568,9 @@
                 <a:ea typeface="Aptos"/>
                 <a:cs typeface="Aptos"/>
               </a:rPr>
-              <a:t>1000 eğitim + 100 test. RF: F1=0.114214, AUC=0.11824. GB en yüksek AUC=0.111436.</a:t>
+              <a:t>1000 eğitim + 100 test.
+F1 ve Accuracy'ye göre → RF en iyi (F1=0.743, Acc=0.73)
+AUC'ye göre → GB en iyi (AUC=0.794)</a:t>
             </a:r>
           </a:p>
         </p:txBody>
@@ -12303,7 +12305,7 @@
                 <a:ea typeface="Aptos"/>
                 <a:cs typeface="Aptos"/>
               </a:rPr>
-              <a:t>Logistic Regression doğrusal karar sınırı kullandığı için sınırlı kaldı. Random Forest, mean_first10, mean_last10, q115 gibi özellikler arasındaki doğrusal olmayan etkileşimleri daha iyi yakaladı.</a:t>
+              <a:t>Logistic Regression doğrusal karar sınırı kullandığı için sınırlı kaldı. Random Forest, mean_first10, mean_last10, q75 gibi özellikler arasındaki doğrusal olmayan etkileşimleri daha iyi yakaladı.</a:t>
             </a:r>
           </a:p>
         </p:txBody>
@@ -12556,74 +12558,29 @@
                 <a:ea typeface="Aptos"/>
                 <a:cs typeface="Aptos"/>
               </a:rPr>
-              <a:t>Test kümesi 50 doğru + 50 yanlış = 100 örnekten oluşan dengeli final settir.</a:t>
-            </a:r>
-          </a:p>
-        </p:txBody>
-      </p:sp>
-      <p:sp>
-        <p:nvSpPr>
-          <p:cNvPr id="3" name="">
-            <a:extLst xmlns:a="http://schemas.openxmlformats.org/drawingml/2006/main">
-              <a:ext uri="{FF2B5EF4-FFF2-40B4-BE49-F238E27FC236}">
-                <a16:creationId xmlns:a16="http://schemas.microsoft.com/office/drawing/2014/main" id="{E284A2E4-A62C-4596-91A7-B5EDC4018B3F}"/>
-              </a:ext>
-            </a:extLst>
-          </p:cNvPr>
-          <p:cNvSpPr>
-            <a:spLocks xmlns:a="http://schemas.openxmlformats.org/drawingml/2006/main" noGrp="1"/>
-          </p:cNvSpPr>
-          <p:nvPr/>
-        </p:nvSpPr>
-        <p:spPr>
-          <a:xfrm xmlns:a="http://schemas.openxmlformats.org/drawingml/2006/main">
-            <a:off x="704850" y="1524000"/>
-            <a:ext cx="3238500" cy="3714750"/>
-          </a:xfrm>
-          <a:prstGeom xmlns:a="http://schemas.openxmlformats.org/drawingml/2006/main" prst="roundRect">
-            <a:avLst>
-              <a:gd name="adj" fmla="val 3529"/>
-            </a:avLst>
-          </a:prstGeom>
-          <a:solidFill xmlns:a="http://schemas.openxmlformats.org/drawingml/2006/main">
-            <a:srgbClr val="FFFFFF"/>
-          </a:solidFill>
-          <a:ln xmlns:a="http://schemas.openxmlformats.org/drawingml/2006/main" w="9525">
-            <a:solidFill>
-              <a:srgbClr val="CBD5E1"/>
-            </a:solidFill>
-            <a:prstDash val="solid"/>
-          </a:ln>
-        </p:spPr>
-        <p:style>
-          <a:lnRef xmlns:a="http://schemas.openxmlformats.org/drawingml/2006/main" idx="0"/>
-          <a:fillRef xmlns:a="http://schemas.openxmlformats.org/drawingml/2006/main" idx="0"/>
-          <a:effectRef xmlns:a="http://schemas.openxmlformats.org/drawingml/2006/main" idx="4"/>
-          <a:fontRef xmlns:a="http://schemas.openxmlformats.org/drawingml/2006/main" idx="major"/>
-        </p:style>
-        <p:txBody xmlns:a="http://schemas.openxmlformats.org/drawingml/2006/main">
-          <a:bodyPr/>
-          <a:p/>
-        </p:txBody>
-      </p:sp>
-      <p:sp>
-        <p:nvSpPr>
-          <p:cNvPr id="4" name="">
-            <a:extLst xmlns:a="http://schemas.openxmlformats.org/drawingml/2006/main">
-              <a:ext uri="{FF2B5EF4-FFF2-40B4-BE49-F238E27FC236}">
-                <a16:creationId xmlns:a16="http://schemas.microsoft.com/office/drawing/2014/main" id="{DD87B2E6-3CE5-4A7F-8C61-864C6B34091B}"/>
-              </a:ext>
-            </a:extLst>
-          </p:cNvPr>
-          <p:cNvSpPr>
-            <a:spLocks xmlns:a="http://schemas.openxmlformats.org/drawingml/2006/main" noGrp="1"/>
-          </p:cNvSpPr>
-          <p:nvPr/>
-        </p:nvSpPr>
-        <p:spPr>
-          <a:xfrm xmlns:a="http://schemas.openxmlformats.org/drawingml/2006/main">
-            <a:off x="933450" y="1790700"/>
-            <a:ext cx="2781300" cy="247650"/>
+              <a:t>Test kümesi 50 doğru + 50 yanlış örnekten oluşan dengeli final settir.</a:t>
+            </a:r>
+          </a:p>
+        </p:txBody>
+      </p:sp>
+      <p:sp>
+        <p:nvSpPr>
+          <p:cNvPr id="48" name="">
+            <a:extLst xmlns:a="http://schemas.openxmlformats.org/drawingml/2006/main">
+              <a:ext uri="{FF2B5EF4-FFF2-40B4-BE49-F238E27FC236}">
+                <a16:creationId xmlns:a16="http://schemas.microsoft.com/office/drawing/2014/main" id="{D5EAF6E0-9556-4BE6-A5EC-702ED67A82B5}"/>
+              </a:ext>
+            </a:extLst>
+          </p:cNvPr>
+          <p:cNvSpPr>
+            <a:spLocks xmlns:a="http://schemas.openxmlformats.org/drawingml/2006/main" noGrp="1"/>
+          </p:cNvSpPr>
+          <p:nvPr/>
+        </p:nvSpPr>
+        <p:spPr>
+          <a:xfrm xmlns:a="http://schemas.openxmlformats.org/drawingml/2006/main">
+            <a:off x="685800" y="6496050"/>
+            <a:ext cx="5905500" cy="171450"/>
           </a:xfrm>
           <a:prstGeom xmlns:a="http://schemas.openxmlformats.org/drawingml/2006/main" prst="rect">
             <a:avLst/>
@@ -12639,92 +12596,47 @@
           <a:lstStyle xmlns:a="http://schemas.openxmlformats.org/drawingml/2006/main"/>
           <a:p xmlns:a="http://schemas.openxmlformats.org/drawingml/2006/main">
             <a:pPr>
-              <a:defRPr sz="1575" b="1">
-                <a:solidFill>
-                  <a:srgbClr val="1D4ED8"/>
-                </a:solidFill>
-                <a:latin typeface="Aptos"/>
-                <a:ea typeface="Aptos"/>
-                <a:cs typeface="Aptos"/>
-              </a:defRPr>
-            </a:pPr>
-            <a:r>
-              <a:rPr sz="1575" b="1">
-                <a:solidFill>
-                  <a:srgbClr val="1D4ED8"/>
-                </a:solidFill>
-                <a:latin typeface="Aptos"/>
-                <a:ea typeface="Aptos"/>
-                <a:cs typeface="Aptos"/>
-              </a:rPr>
-              <a:t>Logistic Regression</a:t>
-            </a:r>
-          </a:p>
-        </p:txBody>
-      </p:sp>
-      <p:sp>
-        <p:nvSpPr>
-          <p:cNvPr id="5" name="">
-            <a:extLst xmlns:a="http://schemas.openxmlformats.org/drawingml/2006/main">
-              <a:ext uri="{FF2B5EF4-FFF2-40B4-BE49-F238E27FC236}">
-                <a16:creationId xmlns:a16="http://schemas.microsoft.com/office/drawing/2014/main" id="{340C348E-F8DA-45BE-916C-00EF083AEC45}"/>
-              </a:ext>
-            </a:extLst>
-          </p:cNvPr>
-          <p:cNvSpPr>
-            <a:spLocks xmlns:a="http://schemas.openxmlformats.org/drawingml/2006/main" noGrp="1"/>
-          </p:cNvSpPr>
-          <p:nvPr/>
-        </p:nvSpPr>
-        <p:spPr>
-          <a:xfrm xmlns:a="http://schemas.openxmlformats.org/drawingml/2006/main">
-            <a:off x="1162050" y="2305050"/>
-            <a:ext cx="914400" cy="685800"/>
-          </a:xfrm>
-          <a:prstGeom xmlns:a="http://schemas.openxmlformats.org/drawingml/2006/main" prst="roundRect">
-            <a:avLst>
-              <a:gd name="adj" fmla="val 16667"/>
-            </a:avLst>
-          </a:prstGeom>
-          <a:solidFill xmlns:a="http://schemas.openxmlformats.org/drawingml/2006/main">
-            <a:srgbClr val="ECFDF5"/>
-          </a:solidFill>
-          <a:ln xmlns:a="http://schemas.openxmlformats.org/drawingml/2006/main" w="9525">
-            <a:solidFill>
-              <a:srgbClr val="99F6E4"/>
-            </a:solidFill>
-            <a:prstDash val="solid"/>
-          </a:ln>
-        </p:spPr>
-        <p:style>
-          <a:lnRef xmlns:a="http://schemas.openxmlformats.org/drawingml/2006/main" idx="0"/>
-          <a:fillRef xmlns:a="http://schemas.openxmlformats.org/drawingml/2006/main" idx="0"/>
-          <a:effectRef xmlns:a="http://schemas.openxmlformats.org/drawingml/2006/main" idx="4"/>
-          <a:fontRef xmlns:a="http://schemas.openxmlformats.org/drawingml/2006/main" idx="major"/>
-        </p:style>
-        <p:txBody xmlns:a="http://schemas.openxmlformats.org/drawingml/2006/main">
-          <a:bodyPr/>
-          <a:p/>
-        </p:txBody>
-      </p:sp>
-      <p:sp>
-        <p:nvSpPr>
-          <p:cNvPr id="6" name="">
-            <a:extLst xmlns:a="http://schemas.openxmlformats.org/drawingml/2006/main">
-              <a:ext uri="{FF2B5EF4-FFF2-40B4-BE49-F238E27FC236}">
-                <a16:creationId xmlns:a16="http://schemas.microsoft.com/office/drawing/2014/main" id="{6D478412-E200-409B-9387-295836D6021A}"/>
-              </a:ext>
-            </a:extLst>
-          </p:cNvPr>
-          <p:cNvSpPr>
-            <a:spLocks xmlns:a="http://schemas.openxmlformats.org/drawingml/2006/main" noGrp="1"/>
-          </p:cNvSpPr>
-          <p:nvPr/>
-        </p:nvSpPr>
-        <p:spPr>
-          <a:xfrm xmlns:a="http://schemas.openxmlformats.org/drawingml/2006/main">
-            <a:off x="1276350" y="2400300"/>
-            <a:ext cx="685800" cy="171450"/>
+              <a:defRPr sz="825">
+                <a:solidFill>
+                  <a:srgbClr val="64748B"/>
+                </a:solidFill>
+                <a:latin typeface="Aptos"/>
+                <a:ea typeface="Aptos"/>
+                <a:cs typeface="Aptos"/>
+              </a:defRPr>
+            </a:pPr>
+            <a:r>
+              <a:rPr sz="825">
+                <a:solidFill>
+                  <a:srgbClr val="64748B"/>
+                </a:solidFill>
+                <a:latin typeface="Aptos"/>
+                <a:ea typeface="Aptos"/>
+                <a:cs typeface="Aptos"/>
+              </a:rPr>
+              <a:t>Cosmos-T1 top1-top2 güven sinyali  ·  Betül Arslan</a:t>
+            </a:r>
+          </a:p>
+        </p:txBody>
+      </p:sp>
+      <p:sp>
+        <p:nvSpPr>
+          <p:cNvPr id="49" name="">
+            <a:extLst xmlns:a="http://schemas.openxmlformats.org/drawingml/2006/main">
+              <a:ext uri="{FF2B5EF4-FFF2-40B4-BE49-F238E27FC236}">
+                <a16:creationId xmlns:a16="http://schemas.microsoft.com/office/drawing/2014/main" id="{4224BDB9-B35E-4E02-8207-01D206B5807C}"/>
+              </a:ext>
+            </a:extLst>
+          </p:cNvPr>
+          <p:cNvSpPr>
+            <a:spLocks xmlns:a="http://schemas.openxmlformats.org/drawingml/2006/main" noGrp="1"/>
+          </p:cNvSpPr>
+          <p:nvPr/>
+        </p:nvSpPr>
+        <p:spPr>
+          <a:xfrm xmlns:a="http://schemas.openxmlformats.org/drawingml/2006/main">
+            <a:off x="11201400" y="6496050"/>
+            <a:ext cx="304800" cy="171450"/>
           </a:xfrm>
           <a:prstGeom xmlns:a="http://schemas.openxmlformats.org/drawingml/2006/main" prst="rect">
             <a:avLst/>
@@ -12739,2271 +12651,6 @@
           <a:bodyPr xmlns:a="http://schemas.openxmlformats.org/drawingml/2006/main"/>
           <a:lstStyle xmlns:a="http://schemas.openxmlformats.org/drawingml/2006/main"/>
           <a:p xmlns:a="http://schemas.openxmlformats.org/drawingml/2006/main">
-            <a:pPr algn="ctr">
-              <a:defRPr sz="900" b="1">
-                <a:solidFill>
-                  <a:srgbClr val="475569"/>
-                </a:solidFill>
-                <a:latin typeface="Aptos"/>
-                <a:ea typeface="Aptos"/>
-                <a:cs typeface="Aptos"/>
-              </a:defRPr>
-            </a:pPr>
-            <a:r>
-              <a:rPr sz="900" b="1">
-                <a:solidFill>
-                  <a:srgbClr val="475569"/>
-                </a:solidFill>
-                <a:latin typeface="Aptos"/>
-                <a:ea typeface="Aptos"/>
-                <a:cs typeface="Aptos"/>
-              </a:rPr>
-              <a:t>TN</a:t>
-            </a:r>
-          </a:p>
-        </p:txBody>
-      </p:sp>
-      <p:sp>
-        <p:nvSpPr>
-          <p:cNvPr id="7" name="">
-            <a:extLst xmlns:a="http://schemas.openxmlformats.org/drawingml/2006/main">
-              <a:ext uri="{FF2B5EF4-FFF2-40B4-BE49-F238E27FC236}">
-                <a16:creationId xmlns:a16="http://schemas.microsoft.com/office/drawing/2014/main" id="{5613788D-93A2-4808-873A-401DDFF7EFC0}"/>
-              </a:ext>
-            </a:extLst>
-          </p:cNvPr>
-          <p:cNvSpPr>
-            <a:spLocks xmlns:a="http://schemas.openxmlformats.org/drawingml/2006/main" noGrp="1"/>
-          </p:cNvSpPr>
-          <p:nvPr/>
-        </p:nvSpPr>
-        <p:spPr>
-          <a:xfrm xmlns:a="http://schemas.openxmlformats.org/drawingml/2006/main">
-            <a:off x="1276350" y="2590800"/>
-            <a:ext cx="685800" cy="285750"/>
-          </a:xfrm>
-          <a:prstGeom xmlns:a="http://schemas.openxmlformats.org/drawingml/2006/main" prst="rect">
-            <a:avLst/>
-          </a:prstGeom>
-          <a:noFill xmlns:a="http://schemas.openxmlformats.org/drawingml/2006/main"/>
-          <a:ln xmlns:a="http://schemas.openxmlformats.org/drawingml/2006/main" w="0">
-            <a:noFill/>
-            <a:prstDash val="solid"/>
-          </a:ln>
-        </p:spPr>
-        <p:txBody>
-          <a:bodyPr xmlns:a="http://schemas.openxmlformats.org/drawingml/2006/main"/>
-          <a:lstStyle xmlns:a="http://schemas.openxmlformats.org/drawingml/2006/main"/>
-          <a:p xmlns:a="http://schemas.openxmlformats.org/drawingml/2006/main">
-            <a:pPr algn="ctr">
-              <a:defRPr sz="1950" b="1">
-                <a:solidFill>
-                  <a:srgbClr val="15803D"/>
-                </a:solidFill>
-                <a:latin typeface="Aptos"/>
-                <a:ea typeface="Aptos"/>
-                <a:cs typeface="Aptos"/>
-              </a:defRPr>
-            </a:pPr>
-            <a:r>
-              <a:rPr sz="1950" b="1">
-                <a:solidFill>
-                  <a:srgbClr val="15803D"/>
-                </a:solidFill>
-                <a:latin typeface="Aptos"/>
-                <a:ea typeface="Aptos"/>
-                <a:cs typeface="Aptos"/>
-              </a:rPr>
-              <a:t>34</a:t>
-            </a:r>
-          </a:p>
-        </p:txBody>
-      </p:sp>
-      <p:sp>
-        <p:nvSpPr>
-          <p:cNvPr id="8" name="">
-            <a:extLst xmlns:a="http://schemas.openxmlformats.org/drawingml/2006/main">
-              <a:ext uri="{FF2B5EF4-FFF2-40B4-BE49-F238E27FC236}">
-                <a16:creationId xmlns:a16="http://schemas.microsoft.com/office/drawing/2014/main" id="{C079825C-5507-4AC5-B98D-A184842DF5E4}"/>
-              </a:ext>
-            </a:extLst>
-          </p:cNvPr>
-          <p:cNvSpPr>
-            <a:spLocks xmlns:a="http://schemas.openxmlformats.org/drawingml/2006/main" noGrp="1"/>
-          </p:cNvSpPr>
-          <p:nvPr/>
-        </p:nvSpPr>
-        <p:spPr>
-          <a:xfrm xmlns:a="http://schemas.openxmlformats.org/drawingml/2006/main">
-            <a:off x="2266950" y="2305050"/>
-            <a:ext cx="914400" cy="685800"/>
-          </a:xfrm>
-          <a:prstGeom xmlns:a="http://schemas.openxmlformats.org/drawingml/2006/main" prst="roundRect">
-            <a:avLst>
-              <a:gd name="adj" fmla="val 16667"/>
-            </a:avLst>
-          </a:prstGeom>
-          <a:solidFill xmlns:a="http://schemas.openxmlformats.org/drawingml/2006/main">
-            <a:srgbClr val="FEF2F2"/>
-          </a:solidFill>
-          <a:ln xmlns:a="http://schemas.openxmlformats.org/drawingml/2006/main" w="9525">
-            <a:solidFill>
-              <a:srgbClr val="FECACA"/>
-            </a:solidFill>
-            <a:prstDash val="solid"/>
-          </a:ln>
-        </p:spPr>
-        <p:style>
-          <a:lnRef xmlns:a="http://schemas.openxmlformats.org/drawingml/2006/main" idx="0"/>
-          <a:fillRef xmlns:a="http://schemas.openxmlformats.org/drawingml/2006/main" idx="0"/>
-          <a:effectRef xmlns:a="http://schemas.openxmlformats.org/drawingml/2006/main" idx="4"/>
-          <a:fontRef xmlns:a="http://schemas.openxmlformats.org/drawingml/2006/main" idx="major"/>
-        </p:style>
-        <p:txBody xmlns:a="http://schemas.openxmlformats.org/drawingml/2006/main">
-          <a:bodyPr/>
-          <a:p/>
-        </p:txBody>
-      </p:sp>
-      <p:sp>
-        <p:nvSpPr>
-          <p:cNvPr id="9" name="">
-            <a:extLst xmlns:a="http://schemas.openxmlformats.org/drawingml/2006/main">
-              <a:ext uri="{FF2B5EF4-FFF2-40B4-BE49-F238E27FC236}">
-                <a16:creationId xmlns:a16="http://schemas.microsoft.com/office/drawing/2014/main" id="{56831A67-2729-4AA8-81D7-B9235F82E4BD}"/>
-              </a:ext>
-            </a:extLst>
-          </p:cNvPr>
-          <p:cNvSpPr>
-            <a:spLocks xmlns:a="http://schemas.openxmlformats.org/drawingml/2006/main" noGrp="1"/>
-          </p:cNvSpPr>
-          <p:nvPr/>
-        </p:nvSpPr>
-        <p:spPr>
-          <a:xfrm xmlns:a="http://schemas.openxmlformats.org/drawingml/2006/main">
-            <a:off x="2381250" y="2400300"/>
-            <a:ext cx="685800" cy="171450"/>
-          </a:xfrm>
-          <a:prstGeom xmlns:a="http://schemas.openxmlformats.org/drawingml/2006/main" prst="rect">
-            <a:avLst/>
-          </a:prstGeom>
-          <a:noFill xmlns:a="http://schemas.openxmlformats.org/drawingml/2006/main"/>
-          <a:ln xmlns:a="http://schemas.openxmlformats.org/drawingml/2006/main" w="0">
-            <a:noFill/>
-            <a:prstDash val="solid"/>
-          </a:ln>
-        </p:spPr>
-        <p:txBody>
-          <a:bodyPr xmlns:a="http://schemas.openxmlformats.org/drawingml/2006/main"/>
-          <a:lstStyle xmlns:a="http://schemas.openxmlformats.org/drawingml/2006/main"/>
-          <a:p xmlns:a="http://schemas.openxmlformats.org/drawingml/2006/main">
-            <a:pPr algn="ctr">
-              <a:defRPr sz="900" b="1">
-                <a:solidFill>
-                  <a:srgbClr val="475569"/>
-                </a:solidFill>
-                <a:latin typeface="Aptos"/>
-                <a:ea typeface="Aptos"/>
-                <a:cs typeface="Aptos"/>
-              </a:defRPr>
-            </a:pPr>
-            <a:r>
-              <a:rPr sz="900" b="1">
-                <a:solidFill>
-                  <a:srgbClr val="475569"/>
-                </a:solidFill>
-                <a:latin typeface="Aptos"/>
-                <a:ea typeface="Aptos"/>
-                <a:cs typeface="Aptos"/>
-              </a:rPr>
-              <a:t>FP</a:t>
-            </a:r>
-          </a:p>
-        </p:txBody>
-      </p:sp>
-      <p:sp>
-        <p:nvSpPr>
-          <p:cNvPr id="10" name="">
-            <a:extLst xmlns:a="http://schemas.openxmlformats.org/drawingml/2006/main">
-              <a:ext uri="{FF2B5EF4-FFF2-40B4-BE49-F238E27FC236}">
-                <a16:creationId xmlns:a16="http://schemas.microsoft.com/office/drawing/2014/main" id="{802894CE-273B-45F3-8C71-C166201D0A1A}"/>
-              </a:ext>
-            </a:extLst>
-          </p:cNvPr>
-          <p:cNvSpPr>
-            <a:spLocks xmlns:a="http://schemas.openxmlformats.org/drawingml/2006/main" noGrp="1"/>
-          </p:cNvSpPr>
-          <p:nvPr/>
-        </p:nvSpPr>
-        <p:spPr>
-          <a:xfrm xmlns:a="http://schemas.openxmlformats.org/drawingml/2006/main">
-            <a:off x="2381250" y="2590800"/>
-            <a:ext cx="685800" cy="285750"/>
-          </a:xfrm>
-          <a:prstGeom xmlns:a="http://schemas.openxmlformats.org/drawingml/2006/main" prst="rect">
-            <a:avLst/>
-          </a:prstGeom>
-          <a:noFill xmlns:a="http://schemas.openxmlformats.org/drawingml/2006/main"/>
-          <a:ln xmlns:a="http://schemas.openxmlformats.org/drawingml/2006/main" w="0">
-            <a:noFill/>
-            <a:prstDash val="solid"/>
-          </a:ln>
-        </p:spPr>
-        <p:txBody>
-          <a:bodyPr xmlns:a="http://schemas.openxmlformats.org/drawingml/2006/main"/>
-          <a:lstStyle xmlns:a="http://schemas.openxmlformats.org/drawingml/2006/main"/>
-          <a:p xmlns:a="http://schemas.openxmlformats.org/drawingml/2006/main">
-            <a:pPr algn="ctr">
-              <a:defRPr sz="1950" b="1">
-                <a:solidFill>
-                  <a:srgbClr val="B91C1C"/>
-                </a:solidFill>
-                <a:latin typeface="Aptos"/>
-                <a:ea typeface="Aptos"/>
-                <a:cs typeface="Aptos"/>
-              </a:defRPr>
-            </a:pPr>
-            <a:r>
-              <a:rPr sz="1950" b="1">
-                <a:solidFill>
-                  <a:srgbClr val="B91C1C"/>
-                </a:solidFill>
-                <a:latin typeface="Aptos"/>
-                <a:ea typeface="Aptos"/>
-                <a:cs typeface="Aptos"/>
-              </a:rPr>
-              <a:t>16</a:t>
-            </a:r>
-          </a:p>
-        </p:txBody>
-      </p:sp>
-      <p:sp>
-        <p:nvSpPr>
-          <p:cNvPr id="11" name="">
-            <a:extLst xmlns:a="http://schemas.openxmlformats.org/drawingml/2006/main">
-              <a:ext uri="{FF2B5EF4-FFF2-40B4-BE49-F238E27FC236}">
-                <a16:creationId xmlns:a16="http://schemas.microsoft.com/office/drawing/2014/main" id="{5E5D608F-E62F-417E-A64C-175B0D9DC779}"/>
-              </a:ext>
-            </a:extLst>
-          </p:cNvPr>
-          <p:cNvSpPr>
-            <a:spLocks xmlns:a="http://schemas.openxmlformats.org/drawingml/2006/main" noGrp="1"/>
-          </p:cNvSpPr>
-          <p:nvPr/>
-        </p:nvSpPr>
-        <p:spPr>
-          <a:xfrm xmlns:a="http://schemas.openxmlformats.org/drawingml/2006/main">
-            <a:off x="1162050" y="3181350"/>
-            <a:ext cx="914400" cy="685800"/>
-          </a:xfrm>
-          <a:prstGeom xmlns:a="http://schemas.openxmlformats.org/drawingml/2006/main" prst="roundRect">
-            <a:avLst>
-              <a:gd name="adj" fmla="val 16667"/>
-            </a:avLst>
-          </a:prstGeom>
-          <a:solidFill xmlns:a="http://schemas.openxmlformats.org/drawingml/2006/main">
-            <a:srgbClr val="FEF2F2"/>
-          </a:solidFill>
-          <a:ln xmlns:a="http://schemas.openxmlformats.org/drawingml/2006/main" w="9525">
-            <a:solidFill>
-              <a:srgbClr val="FECACA"/>
-            </a:solidFill>
-            <a:prstDash val="solid"/>
-          </a:ln>
-        </p:spPr>
-        <p:style>
-          <a:lnRef xmlns:a="http://schemas.openxmlformats.org/drawingml/2006/main" idx="0"/>
-          <a:fillRef xmlns:a="http://schemas.openxmlformats.org/drawingml/2006/main" idx="0"/>
-          <a:effectRef xmlns:a="http://schemas.openxmlformats.org/drawingml/2006/main" idx="4"/>
-          <a:fontRef xmlns:a="http://schemas.openxmlformats.org/drawingml/2006/main" idx="major"/>
-        </p:style>
-        <p:txBody xmlns:a="http://schemas.openxmlformats.org/drawingml/2006/main">
-          <a:bodyPr/>
-          <a:p/>
-        </p:txBody>
-      </p:sp>
-      <p:sp>
-        <p:nvSpPr>
-          <p:cNvPr id="12" name="">
-            <a:extLst xmlns:a="http://schemas.openxmlformats.org/drawingml/2006/main">
-              <a:ext uri="{FF2B5EF4-FFF2-40B4-BE49-F238E27FC236}">
-                <a16:creationId xmlns:a16="http://schemas.microsoft.com/office/drawing/2014/main" id="{F14CCD7C-3341-406D-ACD4-D4AF6086ACCF}"/>
-              </a:ext>
-            </a:extLst>
-          </p:cNvPr>
-          <p:cNvSpPr>
-            <a:spLocks xmlns:a="http://schemas.openxmlformats.org/drawingml/2006/main" noGrp="1"/>
-          </p:cNvSpPr>
-          <p:nvPr/>
-        </p:nvSpPr>
-        <p:spPr>
-          <a:xfrm xmlns:a="http://schemas.openxmlformats.org/drawingml/2006/main">
-            <a:off x="1276350" y="3276600"/>
-            <a:ext cx="685800" cy="171450"/>
-          </a:xfrm>
-          <a:prstGeom xmlns:a="http://schemas.openxmlformats.org/drawingml/2006/main" prst="rect">
-            <a:avLst/>
-          </a:prstGeom>
-          <a:noFill xmlns:a="http://schemas.openxmlformats.org/drawingml/2006/main"/>
-          <a:ln xmlns:a="http://schemas.openxmlformats.org/drawingml/2006/main" w="0">
-            <a:noFill/>
-            <a:prstDash val="solid"/>
-          </a:ln>
-        </p:spPr>
-        <p:txBody>
-          <a:bodyPr xmlns:a="http://schemas.openxmlformats.org/drawingml/2006/main"/>
-          <a:lstStyle xmlns:a="http://schemas.openxmlformats.org/drawingml/2006/main"/>
-          <a:p xmlns:a="http://schemas.openxmlformats.org/drawingml/2006/main">
-            <a:pPr algn="ctr">
-              <a:defRPr sz="900" b="1">
-                <a:solidFill>
-                  <a:srgbClr val="475569"/>
-                </a:solidFill>
-                <a:latin typeface="Aptos"/>
-                <a:ea typeface="Aptos"/>
-                <a:cs typeface="Aptos"/>
-              </a:defRPr>
-            </a:pPr>
-            <a:r>
-              <a:rPr sz="900" b="1">
-                <a:solidFill>
-                  <a:srgbClr val="475569"/>
-                </a:solidFill>
-                <a:latin typeface="Aptos"/>
-                <a:ea typeface="Aptos"/>
-                <a:cs typeface="Aptos"/>
-              </a:rPr>
-              <a:t>FN</a:t>
-            </a:r>
-          </a:p>
-        </p:txBody>
-      </p:sp>
-      <p:sp>
-        <p:nvSpPr>
-          <p:cNvPr id="13" name="">
-            <a:extLst xmlns:a="http://schemas.openxmlformats.org/drawingml/2006/main">
-              <a:ext uri="{FF2B5EF4-FFF2-40B4-BE49-F238E27FC236}">
-                <a16:creationId xmlns:a16="http://schemas.microsoft.com/office/drawing/2014/main" id="{0A5B61CC-58E9-4289-8B44-1F1D8671F2AB}"/>
-              </a:ext>
-            </a:extLst>
-          </p:cNvPr>
-          <p:cNvSpPr>
-            <a:spLocks xmlns:a="http://schemas.openxmlformats.org/drawingml/2006/main" noGrp="1"/>
-          </p:cNvSpPr>
-          <p:nvPr/>
-        </p:nvSpPr>
-        <p:spPr>
-          <a:xfrm xmlns:a="http://schemas.openxmlformats.org/drawingml/2006/main">
-            <a:off x="1276350" y="3467100"/>
-            <a:ext cx="685800" cy="285750"/>
-          </a:xfrm>
-          <a:prstGeom xmlns:a="http://schemas.openxmlformats.org/drawingml/2006/main" prst="rect">
-            <a:avLst/>
-          </a:prstGeom>
-          <a:noFill xmlns:a="http://schemas.openxmlformats.org/drawingml/2006/main"/>
-          <a:ln xmlns:a="http://schemas.openxmlformats.org/drawingml/2006/main" w="0">
-            <a:noFill/>
-            <a:prstDash val="solid"/>
-          </a:ln>
-        </p:spPr>
-        <p:txBody>
-          <a:bodyPr xmlns:a="http://schemas.openxmlformats.org/drawingml/2006/main"/>
-          <a:lstStyle xmlns:a="http://schemas.openxmlformats.org/drawingml/2006/main"/>
-          <a:p xmlns:a="http://schemas.openxmlformats.org/drawingml/2006/main">
-            <a:pPr algn="ctr">
-              <a:defRPr sz="1950" b="1">
-                <a:solidFill>
-                  <a:srgbClr val="B91C1C"/>
-                </a:solidFill>
-                <a:latin typeface="Aptos"/>
-                <a:ea typeface="Aptos"/>
-                <a:cs typeface="Aptos"/>
-              </a:defRPr>
-            </a:pPr>
-            <a:r>
-              <a:rPr sz="1950" b="1">
-                <a:solidFill>
-                  <a:srgbClr val="B91C1C"/>
-                </a:solidFill>
-                <a:latin typeface="Aptos"/>
-                <a:ea typeface="Aptos"/>
-                <a:cs typeface="Aptos"/>
-              </a:rPr>
-              <a:t>12</a:t>
-            </a:r>
-          </a:p>
-        </p:txBody>
-      </p:sp>
-      <p:sp>
-        <p:nvSpPr>
-          <p:cNvPr id="14" name="">
-            <a:extLst xmlns:a="http://schemas.openxmlformats.org/drawingml/2006/main">
-              <a:ext uri="{FF2B5EF4-FFF2-40B4-BE49-F238E27FC236}">
-                <a16:creationId xmlns:a16="http://schemas.microsoft.com/office/drawing/2014/main" id="{ABA12CE2-7EC5-4D61-9A82-D7F147EE5143}"/>
-              </a:ext>
-            </a:extLst>
-          </p:cNvPr>
-          <p:cNvSpPr>
-            <a:spLocks xmlns:a="http://schemas.openxmlformats.org/drawingml/2006/main" noGrp="1"/>
-          </p:cNvSpPr>
-          <p:nvPr/>
-        </p:nvSpPr>
-        <p:spPr>
-          <a:xfrm xmlns:a="http://schemas.openxmlformats.org/drawingml/2006/main">
-            <a:off x="2266950" y="3181350"/>
-            <a:ext cx="914400" cy="685800"/>
-          </a:xfrm>
-          <a:prstGeom xmlns:a="http://schemas.openxmlformats.org/drawingml/2006/main" prst="roundRect">
-            <a:avLst>
-              <a:gd name="adj" fmla="val 16667"/>
-            </a:avLst>
-          </a:prstGeom>
-          <a:solidFill xmlns:a="http://schemas.openxmlformats.org/drawingml/2006/main">
-            <a:srgbClr val="ECFDF5"/>
-          </a:solidFill>
-          <a:ln xmlns:a="http://schemas.openxmlformats.org/drawingml/2006/main" w="9525">
-            <a:solidFill>
-              <a:srgbClr val="99F6E4"/>
-            </a:solidFill>
-            <a:prstDash val="solid"/>
-          </a:ln>
-        </p:spPr>
-        <p:style>
-          <a:lnRef xmlns:a="http://schemas.openxmlformats.org/drawingml/2006/main" idx="0"/>
-          <a:fillRef xmlns:a="http://schemas.openxmlformats.org/drawingml/2006/main" idx="0"/>
-          <a:effectRef xmlns:a="http://schemas.openxmlformats.org/drawingml/2006/main" idx="4"/>
-          <a:fontRef xmlns:a="http://schemas.openxmlformats.org/drawingml/2006/main" idx="major"/>
-        </p:style>
-        <p:txBody xmlns:a="http://schemas.openxmlformats.org/drawingml/2006/main">
-          <a:bodyPr/>
-          <a:p/>
-        </p:txBody>
-      </p:sp>
-      <p:sp>
-        <p:nvSpPr>
-          <p:cNvPr id="15" name="">
-            <a:extLst xmlns:a="http://schemas.openxmlformats.org/drawingml/2006/main">
-              <a:ext uri="{FF2B5EF4-FFF2-40B4-BE49-F238E27FC236}">
-                <a16:creationId xmlns:a16="http://schemas.microsoft.com/office/drawing/2014/main" id="{D5D4C1DD-EBEA-4384-81B4-FBAF18516753}"/>
-              </a:ext>
-            </a:extLst>
-          </p:cNvPr>
-          <p:cNvSpPr>
-            <a:spLocks xmlns:a="http://schemas.openxmlformats.org/drawingml/2006/main" noGrp="1"/>
-          </p:cNvSpPr>
-          <p:nvPr/>
-        </p:nvSpPr>
-        <p:spPr>
-          <a:xfrm xmlns:a="http://schemas.openxmlformats.org/drawingml/2006/main">
-            <a:off x="2381250" y="3276600"/>
-            <a:ext cx="685800" cy="171450"/>
-          </a:xfrm>
-          <a:prstGeom xmlns:a="http://schemas.openxmlformats.org/drawingml/2006/main" prst="rect">
-            <a:avLst/>
-          </a:prstGeom>
-          <a:noFill xmlns:a="http://schemas.openxmlformats.org/drawingml/2006/main"/>
-          <a:ln xmlns:a="http://schemas.openxmlformats.org/drawingml/2006/main" w="0">
-            <a:noFill/>
-            <a:prstDash val="solid"/>
-          </a:ln>
-        </p:spPr>
-        <p:txBody>
-          <a:bodyPr xmlns:a="http://schemas.openxmlformats.org/drawingml/2006/main"/>
-          <a:lstStyle xmlns:a="http://schemas.openxmlformats.org/drawingml/2006/main"/>
-          <a:p xmlns:a="http://schemas.openxmlformats.org/drawingml/2006/main">
-            <a:pPr algn="ctr">
-              <a:defRPr sz="900" b="1">
-                <a:solidFill>
-                  <a:srgbClr val="475569"/>
-                </a:solidFill>
-                <a:latin typeface="Aptos"/>
-                <a:ea typeface="Aptos"/>
-                <a:cs typeface="Aptos"/>
-              </a:defRPr>
-            </a:pPr>
-            <a:r>
-              <a:rPr sz="900" b="1">
-                <a:solidFill>
-                  <a:srgbClr val="475569"/>
-                </a:solidFill>
-                <a:latin typeface="Aptos"/>
-                <a:ea typeface="Aptos"/>
-                <a:cs typeface="Aptos"/>
-              </a:rPr>
-              <a:t>TP</a:t>
-            </a:r>
-          </a:p>
-        </p:txBody>
-      </p:sp>
-      <p:sp>
-        <p:nvSpPr>
-          <p:cNvPr id="16" name="">
-            <a:extLst xmlns:a="http://schemas.openxmlformats.org/drawingml/2006/main">
-              <a:ext uri="{FF2B5EF4-FFF2-40B4-BE49-F238E27FC236}">
-                <a16:creationId xmlns:a16="http://schemas.microsoft.com/office/drawing/2014/main" id="{7AF46851-1DD4-4350-9023-53F3E95C0873}"/>
-              </a:ext>
-            </a:extLst>
-          </p:cNvPr>
-          <p:cNvSpPr>
-            <a:spLocks xmlns:a="http://schemas.openxmlformats.org/drawingml/2006/main" noGrp="1"/>
-          </p:cNvSpPr>
-          <p:nvPr/>
-        </p:nvSpPr>
-        <p:spPr>
-          <a:xfrm xmlns:a="http://schemas.openxmlformats.org/drawingml/2006/main">
-            <a:off x="2381250" y="3467100"/>
-            <a:ext cx="685800" cy="285750"/>
-          </a:xfrm>
-          <a:prstGeom xmlns:a="http://schemas.openxmlformats.org/drawingml/2006/main" prst="rect">
-            <a:avLst/>
-          </a:prstGeom>
-          <a:noFill xmlns:a="http://schemas.openxmlformats.org/drawingml/2006/main"/>
-          <a:ln xmlns:a="http://schemas.openxmlformats.org/drawingml/2006/main" w="0">
-            <a:noFill/>
-            <a:prstDash val="solid"/>
-          </a:ln>
-        </p:spPr>
-        <p:txBody>
-          <a:bodyPr xmlns:a="http://schemas.openxmlformats.org/drawingml/2006/main"/>
-          <a:lstStyle xmlns:a="http://schemas.openxmlformats.org/drawingml/2006/main"/>
-          <a:p xmlns:a="http://schemas.openxmlformats.org/drawingml/2006/main">
-            <a:pPr algn="ctr">
-              <a:defRPr sz="1950" b="1">
-                <a:solidFill>
-                  <a:srgbClr val="15803D"/>
-                </a:solidFill>
-                <a:latin typeface="Aptos"/>
-                <a:ea typeface="Aptos"/>
-                <a:cs typeface="Aptos"/>
-              </a:defRPr>
-            </a:pPr>
-            <a:r>
-              <a:rPr sz="1950" b="1">
-                <a:solidFill>
-                  <a:srgbClr val="15803D"/>
-                </a:solidFill>
-                <a:latin typeface="Aptos"/>
-                <a:ea typeface="Aptos"/>
-                <a:cs typeface="Aptos"/>
-              </a:rPr>
-              <a:t>38</a:t>
-            </a:r>
-          </a:p>
-        </p:txBody>
-      </p:sp>
-      <p:sp>
-        <p:nvSpPr>
-          <p:cNvPr id="17" name="">
-            <a:extLst xmlns:a="http://schemas.openxmlformats.org/drawingml/2006/main">
-              <a:ext uri="{FF2B5EF4-FFF2-40B4-BE49-F238E27FC236}">
-                <a16:creationId xmlns:a16="http://schemas.microsoft.com/office/drawing/2014/main" id="{9C334000-E5E2-4F9F-BB46-C9BB71A0849F}"/>
-              </a:ext>
-            </a:extLst>
-          </p:cNvPr>
-          <p:cNvSpPr>
-            <a:spLocks xmlns:a="http://schemas.openxmlformats.org/drawingml/2006/main" noGrp="1"/>
-          </p:cNvSpPr>
-          <p:nvPr/>
-        </p:nvSpPr>
-        <p:spPr>
-          <a:xfrm xmlns:a="http://schemas.openxmlformats.org/drawingml/2006/main">
-            <a:off x="971550" y="4229100"/>
-            <a:ext cx="2705100" cy="552450"/>
-          </a:xfrm>
-          <a:prstGeom xmlns:a="http://schemas.openxmlformats.org/drawingml/2006/main" prst="rect">
-            <a:avLst/>
-          </a:prstGeom>
-          <a:noFill xmlns:a="http://schemas.openxmlformats.org/drawingml/2006/main"/>
-          <a:ln xmlns:a="http://schemas.openxmlformats.org/drawingml/2006/main" w="0">
-            <a:noFill/>
-            <a:prstDash val="solid"/>
-          </a:ln>
-        </p:spPr>
-        <p:txBody>
-          <a:bodyPr xmlns:a="http://schemas.openxmlformats.org/drawingml/2006/main"/>
-          <a:lstStyle xmlns:a="http://schemas.openxmlformats.org/drawingml/2006/main"/>
-          <a:p xmlns:a="http://schemas.openxmlformats.org/drawingml/2006/main">
-            <a:pPr>
-              <a:defRPr sz="1125">
-                <a:solidFill>
-                  <a:srgbClr val="475569"/>
-                </a:solidFill>
-                <a:latin typeface="Aptos"/>
-                <a:ea typeface="Aptos"/>
-                <a:cs typeface="Aptos"/>
-              </a:defRPr>
-            </a:pPr>
-            <a:r>
-              <a:rPr sz="1125">
-                <a:solidFill>
-                  <a:srgbClr val="475569"/>
-                </a:solidFill>
-                <a:latin typeface="Aptos"/>
-                <a:ea typeface="Aptos"/>
-                <a:cs typeface="Aptos"/>
-              </a:rPr>
-              <a:t>FP yüksek: yanlış cevapları doğru sanma riski daha fazla.</a:t>
-            </a:r>
-          </a:p>
-        </p:txBody>
-      </p:sp>
-      <p:sp>
-        <p:nvSpPr>
-          <p:cNvPr id="18" name="">
-            <a:extLst xmlns:a="http://schemas.openxmlformats.org/drawingml/2006/main">
-              <a:ext uri="{FF2B5EF4-FFF2-40B4-BE49-F238E27FC236}">
-                <a16:creationId xmlns:a16="http://schemas.microsoft.com/office/drawing/2014/main" id="{B59341FC-6BE5-45FA-A307-2BEED5A17849}"/>
-              </a:ext>
-            </a:extLst>
-          </p:cNvPr>
-          <p:cNvSpPr>
-            <a:spLocks xmlns:a="http://schemas.openxmlformats.org/drawingml/2006/main" noGrp="1"/>
-          </p:cNvSpPr>
-          <p:nvPr/>
-        </p:nvSpPr>
-        <p:spPr>
-          <a:xfrm xmlns:a="http://schemas.openxmlformats.org/drawingml/2006/main">
-            <a:off x="4381500" y="1524000"/>
-            <a:ext cx="3238500" cy="3714750"/>
-          </a:xfrm>
-          <a:prstGeom xmlns:a="http://schemas.openxmlformats.org/drawingml/2006/main" prst="roundRect">
-            <a:avLst>
-              <a:gd name="adj" fmla="val 3529"/>
-            </a:avLst>
-          </a:prstGeom>
-          <a:solidFill xmlns:a="http://schemas.openxmlformats.org/drawingml/2006/main">
-            <a:srgbClr val="FFFFFF"/>
-          </a:solidFill>
-          <a:ln xmlns:a="http://schemas.openxmlformats.org/drawingml/2006/main" w="9525">
-            <a:solidFill>
-              <a:srgbClr val="CBD5E1"/>
-            </a:solidFill>
-            <a:prstDash val="solid"/>
-          </a:ln>
-        </p:spPr>
-        <p:style>
-          <a:lnRef xmlns:a="http://schemas.openxmlformats.org/drawingml/2006/main" idx="0"/>
-          <a:fillRef xmlns:a="http://schemas.openxmlformats.org/drawingml/2006/main" idx="0"/>
-          <a:effectRef xmlns:a="http://schemas.openxmlformats.org/drawingml/2006/main" idx="4"/>
-          <a:fontRef xmlns:a="http://schemas.openxmlformats.org/drawingml/2006/main" idx="major"/>
-        </p:style>
-        <p:txBody xmlns:a="http://schemas.openxmlformats.org/drawingml/2006/main">
-          <a:bodyPr/>
-          <a:p/>
-        </p:txBody>
-      </p:sp>
-      <p:sp>
-        <p:nvSpPr>
-          <p:cNvPr id="19" name="">
-            <a:extLst xmlns:a="http://schemas.openxmlformats.org/drawingml/2006/main">
-              <a:ext uri="{FF2B5EF4-FFF2-40B4-BE49-F238E27FC236}">
-                <a16:creationId xmlns:a16="http://schemas.microsoft.com/office/drawing/2014/main" id="{2B0CDEA6-36E2-4116-876F-ECBE5212511A}"/>
-              </a:ext>
-            </a:extLst>
-          </p:cNvPr>
-          <p:cNvSpPr>
-            <a:spLocks xmlns:a="http://schemas.openxmlformats.org/drawingml/2006/main" noGrp="1"/>
-          </p:cNvSpPr>
-          <p:nvPr/>
-        </p:nvSpPr>
-        <p:spPr>
-          <a:xfrm xmlns:a="http://schemas.openxmlformats.org/drawingml/2006/main">
-            <a:off x="4610100" y="1790700"/>
-            <a:ext cx="2781300" cy="247650"/>
-          </a:xfrm>
-          <a:prstGeom xmlns:a="http://schemas.openxmlformats.org/drawingml/2006/main" prst="rect">
-            <a:avLst/>
-          </a:prstGeom>
-          <a:noFill xmlns:a="http://schemas.openxmlformats.org/drawingml/2006/main"/>
-          <a:ln xmlns:a="http://schemas.openxmlformats.org/drawingml/2006/main" w="0">
-            <a:noFill/>
-            <a:prstDash val="solid"/>
-          </a:ln>
-        </p:spPr>
-        <p:txBody>
-          <a:bodyPr xmlns:a="http://schemas.openxmlformats.org/drawingml/2006/main"/>
-          <a:lstStyle xmlns:a="http://schemas.openxmlformats.org/drawingml/2006/main"/>
-          <a:p xmlns:a="http://schemas.openxmlformats.org/drawingml/2006/main">
-            <a:pPr>
-              <a:defRPr sz="1575" b="1">
-                <a:solidFill>
-                  <a:srgbClr val="0F766E"/>
-                </a:solidFill>
-                <a:latin typeface="Aptos"/>
-                <a:ea typeface="Aptos"/>
-                <a:cs typeface="Aptos"/>
-              </a:defRPr>
-            </a:pPr>
-            <a:r>
-              <a:rPr sz="1575" b="1">
-                <a:solidFill>
-                  <a:srgbClr val="0F766E"/>
-                </a:solidFill>
-                <a:latin typeface="Aptos"/>
-                <a:ea typeface="Aptos"/>
-                <a:cs typeface="Aptos"/>
-              </a:rPr>
-              <a:t>Random Forest</a:t>
-            </a:r>
-          </a:p>
-        </p:txBody>
-      </p:sp>
-      <p:sp>
-        <p:nvSpPr>
-          <p:cNvPr id="20" name="">
-            <a:extLst xmlns:a="http://schemas.openxmlformats.org/drawingml/2006/main">
-              <a:ext uri="{FF2B5EF4-FFF2-40B4-BE49-F238E27FC236}">
-                <a16:creationId xmlns:a16="http://schemas.microsoft.com/office/drawing/2014/main" id="{7CF00A49-14C7-46CF-9371-3F15F57A2A2F}"/>
-              </a:ext>
-            </a:extLst>
-          </p:cNvPr>
-          <p:cNvSpPr>
-            <a:spLocks xmlns:a="http://schemas.openxmlformats.org/drawingml/2006/main" noGrp="1"/>
-          </p:cNvSpPr>
-          <p:nvPr/>
-        </p:nvSpPr>
-        <p:spPr>
-          <a:xfrm xmlns:a="http://schemas.openxmlformats.org/drawingml/2006/main">
-            <a:off x="4838700" y="2305050"/>
-            <a:ext cx="914400" cy="685800"/>
-          </a:xfrm>
-          <a:prstGeom xmlns:a="http://schemas.openxmlformats.org/drawingml/2006/main" prst="roundRect">
-            <a:avLst>
-              <a:gd name="adj" fmla="val 16667"/>
-            </a:avLst>
-          </a:prstGeom>
-          <a:solidFill xmlns:a="http://schemas.openxmlformats.org/drawingml/2006/main">
-            <a:srgbClr val="ECFDF5"/>
-          </a:solidFill>
-          <a:ln xmlns:a="http://schemas.openxmlformats.org/drawingml/2006/main" w="9525">
-            <a:solidFill>
-              <a:srgbClr val="99F6E4"/>
-            </a:solidFill>
-            <a:prstDash val="solid"/>
-          </a:ln>
-        </p:spPr>
-        <p:style>
-          <a:lnRef xmlns:a="http://schemas.openxmlformats.org/drawingml/2006/main" idx="0"/>
-          <a:fillRef xmlns:a="http://schemas.openxmlformats.org/drawingml/2006/main" idx="0"/>
-          <a:effectRef xmlns:a="http://schemas.openxmlformats.org/drawingml/2006/main" idx="4"/>
-          <a:fontRef xmlns:a="http://schemas.openxmlformats.org/drawingml/2006/main" idx="major"/>
-        </p:style>
-        <p:txBody xmlns:a="http://schemas.openxmlformats.org/drawingml/2006/main">
-          <a:bodyPr/>
-          <a:p/>
-        </p:txBody>
-      </p:sp>
-      <p:sp>
-        <p:nvSpPr>
-          <p:cNvPr id="21" name="">
-            <a:extLst xmlns:a="http://schemas.openxmlformats.org/drawingml/2006/main">
-              <a:ext uri="{FF2B5EF4-FFF2-40B4-BE49-F238E27FC236}">
-                <a16:creationId xmlns:a16="http://schemas.microsoft.com/office/drawing/2014/main" id="{4C1D1F88-DB83-4E16-9FDC-783AB47026E6}"/>
-              </a:ext>
-            </a:extLst>
-          </p:cNvPr>
-          <p:cNvSpPr>
-            <a:spLocks xmlns:a="http://schemas.openxmlformats.org/drawingml/2006/main" noGrp="1"/>
-          </p:cNvSpPr>
-          <p:nvPr/>
-        </p:nvSpPr>
-        <p:spPr>
-          <a:xfrm xmlns:a="http://schemas.openxmlformats.org/drawingml/2006/main">
-            <a:off x="4953000" y="2400300"/>
-            <a:ext cx="685800" cy="171450"/>
-          </a:xfrm>
-          <a:prstGeom xmlns:a="http://schemas.openxmlformats.org/drawingml/2006/main" prst="rect">
-            <a:avLst/>
-          </a:prstGeom>
-          <a:noFill xmlns:a="http://schemas.openxmlformats.org/drawingml/2006/main"/>
-          <a:ln xmlns:a="http://schemas.openxmlformats.org/drawingml/2006/main" w="0">
-            <a:noFill/>
-            <a:prstDash val="solid"/>
-          </a:ln>
-        </p:spPr>
-        <p:txBody>
-          <a:bodyPr xmlns:a="http://schemas.openxmlformats.org/drawingml/2006/main"/>
-          <a:lstStyle xmlns:a="http://schemas.openxmlformats.org/drawingml/2006/main"/>
-          <a:p xmlns:a="http://schemas.openxmlformats.org/drawingml/2006/main">
-            <a:pPr algn="ctr">
-              <a:defRPr sz="900" b="1">
-                <a:solidFill>
-                  <a:srgbClr val="475569"/>
-                </a:solidFill>
-                <a:latin typeface="Aptos"/>
-                <a:ea typeface="Aptos"/>
-                <a:cs typeface="Aptos"/>
-              </a:defRPr>
-            </a:pPr>
-            <a:r>
-              <a:rPr sz="900" b="1">
-                <a:solidFill>
-                  <a:srgbClr val="475569"/>
-                </a:solidFill>
-                <a:latin typeface="Aptos"/>
-                <a:ea typeface="Aptos"/>
-                <a:cs typeface="Aptos"/>
-              </a:rPr>
-              <a:t>TN</a:t>
-            </a:r>
-          </a:p>
-        </p:txBody>
-      </p:sp>
-      <p:sp>
-        <p:nvSpPr>
-          <p:cNvPr id="22" name="">
-            <a:extLst xmlns:a="http://schemas.openxmlformats.org/drawingml/2006/main">
-              <a:ext uri="{FF2B5EF4-FFF2-40B4-BE49-F238E27FC236}">
-                <a16:creationId xmlns:a16="http://schemas.microsoft.com/office/drawing/2014/main" id="{290628C0-A578-41DD-85A2-19C8ED241621}"/>
-              </a:ext>
-            </a:extLst>
-          </p:cNvPr>
-          <p:cNvSpPr>
-            <a:spLocks xmlns:a="http://schemas.openxmlformats.org/drawingml/2006/main" noGrp="1"/>
-          </p:cNvSpPr>
-          <p:nvPr/>
-        </p:nvSpPr>
-        <p:spPr>
-          <a:xfrm xmlns:a="http://schemas.openxmlformats.org/drawingml/2006/main">
-            <a:off x="4953000" y="2590800"/>
-            <a:ext cx="685800" cy="285750"/>
-          </a:xfrm>
-          <a:prstGeom xmlns:a="http://schemas.openxmlformats.org/drawingml/2006/main" prst="rect">
-            <a:avLst/>
-          </a:prstGeom>
-          <a:noFill xmlns:a="http://schemas.openxmlformats.org/drawingml/2006/main"/>
-          <a:ln xmlns:a="http://schemas.openxmlformats.org/drawingml/2006/main" w="0">
-            <a:noFill/>
-            <a:prstDash val="solid"/>
-          </a:ln>
-        </p:spPr>
-        <p:txBody>
-          <a:bodyPr xmlns:a="http://schemas.openxmlformats.org/drawingml/2006/main"/>
-          <a:lstStyle xmlns:a="http://schemas.openxmlformats.org/drawingml/2006/main"/>
-          <a:p xmlns:a="http://schemas.openxmlformats.org/drawingml/2006/main">
-            <a:pPr algn="ctr">
-              <a:defRPr sz="1950" b="1">
-                <a:solidFill>
-                  <a:srgbClr val="15803D"/>
-                </a:solidFill>
-                <a:latin typeface="Aptos"/>
-                <a:ea typeface="Aptos"/>
-                <a:cs typeface="Aptos"/>
-              </a:defRPr>
-            </a:pPr>
-            <a:r>
-              <a:rPr sz="1950" b="1">
-                <a:solidFill>
-                  <a:srgbClr val="15803D"/>
-                </a:solidFill>
-                <a:latin typeface="Aptos"/>
-                <a:ea typeface="Aptos"/>
-                <a:cs typeface="Aptos"/>
-              </a:rPr>
-              <a:t>34</a:t>
-            </a:r>
-          </a:p>
-        </p:txBody>
-      </p:sp>
-      <p:sp>
-        <p:nvSpPr>
-          <p:cNvPr id="23" name="">
-            <a:extLst xmlns:a="http://schemas.openxmlformats.org/drawingml/2006/main">
-              <a:ext uri="{FF2B5EF4-FFF2-40B4-BE49-F238E27FC236}">
-                <a16:creationId xmlns:a16="http://schemas.microsoft.com/office/drawing/2014/main" id="{AA031EF3-3356-4EAF-897F-74DBF21ABFCC}"/>
-              </a:ext>
-            </a:extLst>
-          </p:cNvPr>
-          <p:cNvSpPr>
-            <a:spLocks xmlns:a="http://schemas.openxmlformats.org/drawingml/2006/main" noGrp="1"/>
-          </p:cNvSpPr>
-          <p:nvPr/>
-        </p:nvSpPr>
-        <p:spPr>
-          <a:xfrm xmlns:a="http://schemas.openxmlformats.org/drawingml/2006/main">
-            <a:off x="5943600" y="2305050"/>
-            <a:ext cx="914400" cy="685800"/>
-          </a:xfrm>
-          <a:prstGeom xmlns:a="http://schemas.openxmlformats.org/drawingml/2006/main" prst="roundRect">
-            <a:avLst>
-              <a:gd name="adj" fmla="val 16667"/>
-            </a:avLst>
-          </a:prstGeom>
-          <a:solidFill xmlns:a="http://schemas.openxmlformats.org/drawingml/2006/main">
-            <a:srgbClr val="FEF2F2"/>
-          </a:solidFill>
-          <a:ln xmlns:a="http://schemas.openxmlformats.org/drawingml/2006/main" w="9525">
-            <a:solidFill>
-              <a:srgbClr val="FECACA"/>
-            </a:solidFill>
-            <a:prstDash val="solid"/>
-          </a:ln>
-        </p:spPr>
-        <p:style>
-          <a:lnRef xmlns:a="http://schemas.openxmlformats.org/drawingml/2006/main" idx="0"/>
-          <a:fillRef xmlns:a="http://schemas.openxmlformats.org/drawingml/2006/main" idx="0"/>
-          <a:effectRef xmlns:a="http://schemas.openxmlformats.org/drawingml/2006/main" idx="4"/>
-          <a:fontRef xmlns:a="http://schemas.openxmlformats.org/drawingml/2006/main" idx="major"/>
-        </p:style>
-        <p:txBody xmlns:a="http://schemas.openxmlformats.org/drawingml/2006/main">
-          <a:bodyPr/>
-          <a:p/>
-        </p:txBody>
-      </p:sp>
-      <p:sp>
-        <p:nvSpPr>
-          <p:cNvPr id="24" name="">
-            <a:extLst xmlns:a="http://schemas.openxmlformats.org/drawingml/2006/main">
-              <a:ext uri="{FF2B5EF4-FFF2-40B4-BE49-F238E27FC236}">
-                <a16:creationId xmlns:a16="http://schemas.microsoft.com/office/drawing/2014/main" id="{6BE1417E-5905-4B97-998E-0E68A05370B6}"/>
-              </a:ext>
-            </a:extLst>
-          </p:cNvPr>
-          <p:cNvSpPr>
-            <a:spLocks xmlns:a="http://schemas.openxmlformats.org/drawingml/2006/main" noGrp="1"/>
-          </p:cNvSpPr>
-          <p:nvPr/>
-        </p:nvSpPr>
-        <p:spPr>
-          <a:xfrm xmlns:a="http://schemas.openxmlformats.org/drawingml/2006/main">
-            <a:off x="6057900" y="2400300"/>
-            <a:ext cx="685800" cy="171450"/>
-          </a:xfrm>
-          <a:prstGeom xmlns:a="http://schemas.openxmlformats.org/drawingml/2006/main" prst="rect">
-            <a:avLst/>
-          </a:prstGeom>
-          <a:noFill xmlns:a="http://schemas.openxmlformats.org/drawingml/2006/main"/>
-          <a:ln xmlns:a="http://schemas.openxmlformats.org/drawingml/2006/main" w="0">
-            <a:noFill/>
-            <a:prstDash val="solid"/>
-          </a:ln>
-        </p:spPr>
-        <p:txBody>
-          <a:bodyPr xmlns:a="http://schemas.openxmlformats.org/drawingml/2006/main"/>
-          <a:lstStyle xmlns:a="http://schemas.openxmlformats.org/drawingml/2006/main"/>
-          <a:p xmlns:a="http://schemas.openxmlformats.org/drawingml/2006/main">
-            <a:pPr algn="ctr">
-              <a:defRPr sz="900" b="1">
-                <a:solidFill>
-                  <a:srgbClr val="475569"/>
-                </a:solidFill>
-                <a:latin typeface="Aptos"/>
-                <a:ea typeface="Aptos"/>
-                <a:cs typeface="Aptos"/>
-              </a:defRPr>
-            </a:pPr>
-            <a:r>
-              <a:rPr sz="900" b="1">
-                <a:solidFill>
-                  <a:srgbClr val="475569"/>
-                </a:solidFill>
-                <a:latin typeface="Aptos"/>
-                <a:ea typeface="Aptos"/>
-                <a:cs typeface="Aptos"/>
-              </a:rPr>
-              <a:t>FP</a:t>
-            </a:r>
-          </a:p>
-        </p:txBody>
-      </p:sp>
-      <p:sp>
-        <p:nvSpPr>
-          <p:cNvPr id="25" name="">
-            <a:extLst xmlns:a="http://schemas.openxmlformats.org/drawingml/2006/main">
-              <a:ext uri="{FF2B5EF4-FFF2-40B4-BE49-F238E27FC236}">
-                <a16:creationId xmlns:a16="http://schemas.microsoft.com/office/drawing/2014/main" id="{E952375B-AF0B-44D5-83DA-69723955B675}"/>
-              </a:ext>
-            </a:extLst>
-          </p:cNvPr>
-          <p:cNvSpPr>
-            <a:spLocks xmlns:a="http://schemas.openxmlformats.org/drawingml/2006/main" noGrp="1"/>
-          </p:cNvSpPr>
-          <p:nvPr/>
-        </p:nvSpPr>
-        <p:spPr>
-          <a:xfrm xmlns:a="http://schemas.openxmlformats.org/drawingml/2006/main">
-            <a:off x="6057900" y="2590800"/>
-            <a:ext cx="685800" cy="285750"/>
-          </a:xfrm>
-          <a:prstGeom xmlns:a="http://schemas.openxmlformats.org/drawingml/2006/main" prst="rect">
-            <a:avLst/>
-          </a:prstGeom>
-          <a:noFill xmlns:a="http://schemas.openxmlformats.org/drawingml/2006/main"/>
-          <a:ln xmlns:a="http://schemas.openxmlformats.org/drawingml/2006/main" w="0">
-            <a:noFill/>
-            <a:prstDash val="solid"/>
-          </a:ln>
-        </p:spPr>
-        <p:txBody>
-          <a:bodyPr xmlns:a="http://schemas.openxmlformats.org/drawingml/2006/main"/>
-          <a:lstStyle xmlns:a="http://schemas.openxmlformats.org/drawingml/2006/main"/>
-          <a:p xmlns:a="http://schemas.openxmlformats.org/drawingml/2006/main">
-            <a:pPr algn="ctr">
-              <a:defRPr sz="1950" b="1">
-                <a:solidFill>
-                  <a:srgbClr val="B91C1C"/>
-                </a:solidFill>
-                <a:latin typeface="Aptos"/>
-                <a:ea typeface="Aptos"/>
-                <a:cs typeface="Aptos"/>
-              </a:defRPr>
-            </a:pPr>
-            <a:r>
-              <a:rPr sz="1950" b="1">
-                <a:solidFill>
-                  <a:srgbClr val="B91C1C"/>
-                </a:solidFill>
-                <a:latin typeface="Aptos"/>
-                <a:ea typeface="Aptos"/>
-                <a:cs typeface="Aptos"/>
-              </a:rPr>
-              <a:t>16</a:t>
-            </a:r>
-          </a:p>
-        </p:txBody>
-      </p:sp>
-      <p:sp>
-        <p:nvSpPr>
-          <p:cNvPr id="26" name="">
-            <a:extLst xmlns:a="http://schemas.openxmlformats.org/drawingml/2006/main">
-              <a:ext uri="{FF2B5EF4-FFF2-40B4-BE49-F238E27FC236}">
-                <a16:creationId xmlns:a16="http://schemas.microsoft.com/office/drawing/2014/main" id="{781E1D4B-8239-4FF0-A970-B77EC4AA68AE}"/>
-              </a:ext>
-            </a:extLst>
-          </p:cNvPr>
-          <p:cNvSpPr>
-            <a:spLocks xmlns:a="http://schemas.openxmlformats.org/drawingml/2006/main" noGrp="1"/>
-          </p:cNvSpPr>
-          <p:nvPr/>
-        </p:nvSpPr>
-        <p:spPr>
-          <a:xfrm xmlns:a="http://schemas.openxmlformats.org/drawingml/2006/main">
-            <a:off x="4838700" y="3181350"/>
-            <a:ext cx="914400" cy="685800"/>
-          </a:xfrm>
-          <a:prstGeom xmlns:a="http://schemas.openxmlformats.org/drawingml/2006/main" prst="roundRect">
-            <a:avLst>
-              <a:gd name="adj" fmla="val 16667"/>
-            </a:avLst>
-          </a:prstGeom>
-          <a:solidFill xmlns:a="http://schemas.openxmlformats.org/drawingml/2006/main">
-            <a:srgbClr val="FEF2F2"/>
-          </a:solidFill>
-          <a:ln xmlns:a="http://schemas.openxmlformats.org/drawingml/2006/main" w="9525">
-            <a:solidFill>
-              <a:srgbClr val="FECACA"/>
-            </a:solidFill>
-            <a:prstDash val="solid"/>
-          </a:ln>
-        </p:spPr>
-        <p:style>
-          <a:lnRef xmlns:a="http://schemas.openxmlformats.org/drawingml/2006/main" idx="0"/>
-          <a:fillRef xmlns:a="http://schemas.openxmlformats.org/drawingml/2006/main" idx="0"/>
-          <a:effectRef xmlns:a="http://schemas.openxmlformats.org/drawingml/2006/main" idx="4"/>
-          <a:fontRef xmlns:a="http://schemas.openxmlformats.org/drawingml/2006/main" idx="major"/>
-        </p:style>
-        <p:txBody xmlns:a="http://schemas.openxmlformats.org/drawingml/2006/main">
-          <a:bodyPr/>
-          <a:p/>
-        </p:txBody>
-      </p:sp>
-      <p:sp>
-        <p:nvSpPr>
-          <p:cNvPr id="27" name="">
-            <a:extLst xmlns:a="http://schemas.openxmlformats.org/drawingml/2006/main">
-              <a:ext uri="{FF2B5EF4-FFF2-40B4-BE49-F238E27FC236}">
-                <a16:creationId xmlns:a16="http://schemas.microsoft.com/office/drawing/2014/main" id="{7AA0BF23-F2D9-495C-A552-7DE64E1B28D4}"/>
-              </a:ext>
-            </a:extLst>
-          </p:cNvPr>
-          <p:cNvSpPr>
-            <a:spLocks xmlns:a="http://schemas.openxmlformats.org/drawingml/2006/main" noGrp="1"/>
-          </p:cNvSpPr>
-          <p:nvPr/>
-        </p:nvSpPr>
-        <p:spPr>
-          <a:xfrm xmlns:a="http://schemas.openxmlformats.org/drawingml/2006/main">
-            <a:off x="4953000" y="3276600"/>
-            <a:ext cx="685800" cy="171450"/>
-          </a:xfrm>
-          <a:prstGeom xmlns:a="http://schemas.openxmlformats.org/drawingml/2006/main" prst="rect">
-            <a:avLst/>
-          </a:prstGeom>
-          <a:noFill xmlns:a="http://schemas.openxmlformats.org/drawingml/2006/main"/>
-          <a:ln xmlns:a="http://schemas.openxmlformats.org/drawingml/2006/main" w="0">
-            <a:noFill/>
-            <a:prstDash val="solid"/>
-          </a:ln>
-        </p:spPr>
-        <p:txBody>
-          <a:bodyPr xmlns:a="http://schemas.openxmlformats.org/drawingml/2006/main"/>
-          <a:lstStyle xmlns:a="http://schemas.openxmlformats.org/drawingml/2006/main"/>
-          <a:p xmlns:a="http://schemas.openxmlformats.org/drawingml/2006/main">
-            <a:pPr algn="ctr">
-              <a:defRPr sz="900" b="1">
-                <a:solidFill>
-                  <a:srgbClr val="475569"/>
-                </a:solidFill>
-                <a:latin typeface="Aptos"/>
-                <a:ea typeface="Aptos"/>
-                <a:cs typeface="Aptos"/>
-              </a:defRPr>
-            </a:pPr>
-            <a:r>
-              <a:rPr sz="900" b="1">
-                <a:solidFill>
-                  <a:srgbClr val="475569"/>
-                </a:solidFill>
-                <a:latin typeface="Aptos"/>
-                <a:ea typeface="Aptos"/>
-                <a:cs typeface="Aptos"/>
-              </a:rPr>
-              <a:t>FN</a:t>
-            </a:r>
-          </a:p>
-        </p:txBody>
-      </p:sp>
-      <p:sp>
-        <p:nvSpPr>
-          <p:cNvPr id="28" name="">
-            <a:extLst xmlns:a="http://schemas.openxmlformats.org/drawingml/2006/main">
-              <a:ext uri="{FF2B5EF4-FFF2-40B4-BE49-F238E27FC236}">
-                <a16:creationId xmlns:a16="http://schemas.microsoft.com/office/drawing/2014/main" id="{015E30B7-EB1B-42FA-B32E-54B185D1FA66}"/>
-              </a:ext>
-            </a:extLst>
-          </p:cNvPr>
-          <p:cNvSpPr>
-            <a:spLocks xmlns:a="http://schemas.openxmlformats.org/drawingml/2006/main" noGrp="1"/>
-          </p:cNvSpPr>
-          <p:nvPr/>
-        </p:nvSpPr>
-        <p:spPr>
-          <a:xfrm xmlns:a="http://schemas.openxmlformats.org/drawingml/2006/main">
-            <a:off x="4953000" y="3467100"/>
-            <a:ext cx="685800" cy="285750"/>
-          </a:xfrm>
-          <a:prstGeom xmlns:a="http://schemas.openxmlformats.org/drawingml/2006/main" prst="rect">
-            <a:avLst/>
-          </a:prstGeom>
-          <a:noFill xmlns:a="http://schemas.openxmlformats.org/drawingml/2006/main"/>
-          <a:ln xmlns:a="http://schemas.openxmlformats.org/drawingml/2006/main" w="0">
-            <a:noFill/>
-            <a:prstDash val="solid"/>
-          </a:ln>
-        </p:spPr>
-        <p:txBody>
-          <a:bodyPr xmlns:a="http://schemas.openxmlformats.org/drawingml/2006/main"/>
-          <a:lstStyle xmlns:a="http://schemas.openxmlformats.org/drawingml/2006/main"/>
-          <a:p xmlns:a="http://schemas.openxmlformats.org/drawingml/2006/main">
-            <a:pPr algn="ctr">
-              <a:defRPr sz="1950" b="1">
-                <a:solidFill>
-                  <a:srgbClr val="B91C1C"/>
-                </a:solidFill>
-                <a:latin typeface="Aptos"/>
-                <a:ea typeface="Aptos"/>
-                <a:cs typeface="Aptos"/>
-              </a:defRPr>
-            </a:pPr>
-            <a:r>
-              <a:rPr sz="1950" b="1">
-                <a:solidFill>
-                  <a:srgbClr val="B91C1C"/>
-                </a:solidFill>
-                <a:latin typeface="Aptos"/>
-                <a:ea typeface="Aptos"/>
-                <a:cs typeface="Aptos"/>
-              </a:rPr>
-              <a:t>11</a:t>
-            </a:r>
-          </a:p>
-        </p:txBody>
-      </p:sp>
-      <p:sp>
-        <p:nvSpPr>
-          <p:cNvPr id="29" name="">
-            <a:extLst xmlns:a="http://schemas.openxmlformats.org/drawingml/2006/main">
-              <a:ext uri="{FF2B5EF4-FFF2-40B4-BE49-F238E27FC236}">
-                <a16:creationId xmlns:a16="http://schemas.microsoft.com/office/drawing/2014/main" id="{F4B82D83-5751-47E2-87BD-EA5D6E7A892B}"/>
-              </a:ext>
-            </a:extLst>
-          </p:cNvPr>
-          <p:cNvSpPr>
-            <a:spLocks xmlns:a="http://schemas.openxmlformats.org/drawingml/2006/main" noGrp="1"/>
-          </p:cNvSpPr>
-          <p:nvPr/>
-        </p:nvSpPr>
-        <p:spPr>
-          <a:xfrm xmlns:a="http://schemas.openxmlformats.org/drawingml/2006/main">
-            <a:off x="5943600" y="3181350"/>
-            <a:ext cx="914400" cy="685800"/>
-          </a:xfrm>
-          <a:prstGeom xmlns:a="http://schemas.openxmlformats.org/drawingml/2006/main" prst="roundRect">
-            <a:avLst>
-              <a:gd name="adj" fmla="val 16667"/>
-            </a:avLst>
-          </a:prstGeom>
-          <a:solidFill xmlns:a="http://schemas.openxmlformats.org/drawingml/2006/main">
-            <a:srgbClr val="ECFDF5"/>
-          </a:solidFill>
-          <a:ln xmlns:a="http://schemas.openxmlformats.org/drawingml/2006/main" w="9525">
-            <a:solidFill>
-              <a:srgbClr val="99F6E4"/>
-            </a:solidFill>
-            <a:prstDash val="solid"/>
-          </a:ln>
-        </p:spPr>
-        <p:style>
-          <a:lnRef xmlns:a="http://schemas.openxmlformats.org/drawingml/2006/main" idx="0"/>
-          <a:fillRef xmlns:a="http://schemas.openxmlformats.org/drawingml/2006/main" idx="0"/>
-          <a:effectRef xmlns:a="http://schemas.openxmlformats.org/drawingml/2006/main" idx="4"/>
-          <a:fontRef xmlns:a="http://schemas.openxmlformats.org/drawingml/2006/main" idx="major"/>
-        </p:style>
-        <p:txBody xmlns:a="http://schemas.openxmlformats.org/drawingml/2006/main">
-          <a:bodyPr/>
-          <a:p/>
-        </p:txBody>
-      </p:sp>
-      <p:sp>
-        <p:nvSpPr>
-          <p:cNvPr id="30" name="">
-            <a:extLst xmlns:a="http://schemas.openxmlformats.org/drawingml/2006/main">
-              <a:ext uri="{FF2B5EF4-FFF2-40B4-BE49-F238E27FC236}">
-                <a16:creationId xmlns:a16="http://schemas.microsoft.com/office/drawing/2014/main" id="{93BA43C4-B4D8-42F5-BF57-CE9CC569DB65}"/>
-              </a:ext>
-            </a:extLst>
-          </p:cNvPr>
-          <p:cNvSpPr>
-            <a:spLocks xmlns:a="http://schemas.openxmlformats.org/drawingml/2006/main" noGrp="1"/>
-          </p:cNvSpPr>
-          <p:nvPr/>
-        </p:nvSpPr>
-        <p:spPr>
-          <a:xfrm xmlns:a="http://schemas.openxmlformats.org/drawingml/2006/main">
-            <a:off x="6057900" y="3276600"/>
-            <a:ext cx="685800" cy="171450"/>
-          </a:xfrm>
-          <a:prstGeom xmlns:a="http://schemas.openxmlformats.org/drawingml/2006/main" prst="rect">
-            <a:avLst/>
-          </a:prstGeom>
-          <a:noFill xmlns:a="http://schemas.openxmlformats.org/drawingml/2006/main"/>
-          <a:ln xmlns:a="http://schemas.openxmlformats.org/drawingml/2006/main" w="0">
-            <a:noFill/>
-            <a:prstDash val="solid"/>
-          </a:ln>
-        </p:spPr>
-        <p:txBody>
-          <a:bodyPr xmlns:a="http://schemas.openxmlformats.org/drawingml/2006/main"/>
-          <a:lstStyle xmlns:a="http://schemas.openxmlformats.org/drawingml/2006/main"/>
-          <a:p xmlns:a="http://schemas.openxmlformats.org/drawingml/2006/main">
-            <a:pPr algn="ctr">
-              <a:defRPr sz="900" b="1">
-                <a:solidFill>
-                  <a:srgbClr val="475569"/>
-                </a:solidFill>
-                <a:latin typeface="Aptos"/>
-                <a:ea typeface="Aptos"/>
-                <a:cs typeface="Aptos"/>
-              </a:defRPr>
-            </a:pPr>
-            <a:r>
-              <a:rPr sz="900" b="1">
-                <a:solidFill>
-                  <a:srgbClr val="475569"/>
-                </a:solidFill>
-                <a:latin typeface="Aptos"/>
-                <a:ea typeface="Aptos"/>
-                <a:cs typeface="Aptos"/>
-              </a:rPr>
-              <a:t>TP</a:t>
-            </a:r>
-          </a:p>
-        </p:txBody>
-      </p:sp>
-      <p:sp>
-        <p:nvSpPr>
-          <p:cNvPr id="31" name="">
-            <a:extLst xmlns:a="http://schemas.openxmlformats.org/drawingml/2006/main">
-              <a:ext uri="{FF2B5EF4-FFF2-40B4-BE49-F238E27FC236}">
-                <a16:creationId xmlns:a16="http://schemas.microsoft.com/office/drawing/2014/main" id="{1B8C756B-3E7D-4954-86E8-29B9A2A525A3}"/>
-              </a:ext>
-            </a:extLst>
-          </p:cNvPr>
-          <p:cNvSpPr>
-            <a:spLocks xmlns:a="http://schemas.openxmlformats.org/drawingml/2006/main" noGrp="1"/>
-          </p:cNvSpPr>
-          <p:nvPr/>
-        </p:nvSpPr>
-        <p:spPr>
-          <a:xfrm xmlns:a="http://schemas.openxmlformats.org/drawingml/2006/main">
-            <a:off x="6057900" y="3467100"/>
-            <a:ext cx="685800" cy="285750"/>
-          </a:xfrm>
-          <a:prstGeom xmlns:a="http://schemas.openxmlformats.org/drawingml/2006/main" prst="rect">
-            <a:avLst/>
-          </a:prstGeom>
-          <a:noFill xmlns:a="http://schemas.openxmlformats.org/drawingml/2006/main"/>
-          <a:ln xmlns:a="http://schemas.openxmlformats.org/drawingml/2006/main" w="0">
-            <a:noFill/>
-            <a:prstDash val="solid"/>
-          </a:ln>
-        </p:spPr>
-        <p:txBody>
-          <a:bodyPr xmlns:a="http://schemas.openxmlformats.org/drawingml/2006/main"/>
-          <a:lstStyle xmlns:a="http://schemas.openxmlformats.org/drawingml/2006/main"/>
-          <a:p xmlns:a="http://schemas.openxmlformats.org/drawingml/2006/main">
-            <a:pPr algn="ctr">
-              <a:defRPr sz="1950" b="1">
-                <a:solidFill>
-                  <a:srgbClr val="15803D"/>
-                </a:solidFill>
-                <a:latin typeface="Aptos"/>
-                <a:ea typeface="Aptos"/>
-                <a:cs typeface="Aptos"/>
-              </a:defRPr>
-            </a:pPr>
-            <a:r>
-              <a:rPr sz="1950" b="1">
-                <a:solidFill>
-                  <a:srgbClr val="15803D"/>
-                </a:solidFill>
-                <a:latin typeface="Aptos"/>
-                <a:ea typeface="Aptos"/>
-                <a:cs typeface="Aptos"/>
-              </a:rPr>
-              <a:t>314</a:t>
-            </a:r>
-          </a:p>
-        </p:txBody>
-      </p:sp>
-      <p:sp>
-        <p:nvSpPr>
-          <p:cNvPr id="32" name="">
-            <a:extLst xmlns:a="http://schemas.openxmlformats.org/drawingml/2006/main">
-              <a:ext uri="{FF2B5EF4-FFF2-40B4-BE49-F238E27FC236}">
-                <a16:creationId xmlns:a16="http://schemas.microsoft.com/office/drawing/2014/main" id="{74F94CCE-5FD3-44AE-AA3C-DE82C966460A}"/>
-              </a:ext>
-            </a:extLst>
-          </p:cNvPr>
-          <p:cNvSpPr>
-            <a:spLocks xmlns:a="http://schemas.openxmlformats.org/drawingml/2006/main" noGrp="1"/>
-          </p:cNvSpPr>
-          <p:nvPr/>
-        </p:nvSpPr>
-        <p:spPr>
-          <a:xfrm xmlns:a="http://schemas.openxmlformats.org/drawingml/2006/main">
-            <a:off x="4648200" y="4229100"/>
-            <a:ext cx="2705100" cy="552450"/>
-          </a:xfrm>
-          <a:prstGeom xmlns:a="http://schemas.openxmlformats.org/drawingml/2006/main" prst="rect">
-            <a:avLst/>
-          </a:prstGeom>
-          <a:noFill xmlns:a="http://schemas.openxmlformats.org/drawingml/2006/main"/>
-          <a:ln xmlns:a="http://schemas.openxmlformats.org/drawingml/2006/main" w="0">
-            <a:noFill/>
-            <a:prstDash val="solid"/>
-          </a:ln>
-        </p:spPr>
-        <p:txBody>
-          <a:bodyPr xmlns:a="http://schemas.openxmlformats.org/drawingml/2006/main"/>
-          <a:lstStyle xmlns:a="http://schemas.openxmlformats.org/drawingml/2006/main"/>
-          <a:p xmlns:a="http://schemas.openxmlformats.org/drawingml/2006/main">
-            <a:pPr>
-              <a:defRPr sz="1125">
-                <a:solidFill>
-                  <a:srgbClr val="475569"/>
-                </a:solidFill>
-                <a:latin typeface="Aptos"/>
-                <a:ea typeface="Aptos"/>
-                <a:cs typeface="Aptos"/>
-              </a:defRPr>
-            </a:pPr>
-            <a:r>
-              <a:rPr sz="1125">
-                <a:solidFill>
-                  <a:srgbClr val="475569"/>
-                </a:solidFill>
-                <a:latin typeface="Aptos"/>
-                <a:ea typeface="Aptos"/>
-                <a:cs typeface="Aptos"/>
-              </a:rPr>
-              <a:t>En düşük FN: doğru cevapları kaçırma oranı en düşük.</a:t>
-            </a:r>
-          </a:p>
-        </p:txBody>
-      </p:sp>
-      <p:sp>
-        <p:nvSpPr>
-          <p:cNvPr id="33" name="">
-            <a:extLst xmlns:a="http://schemas.openxmlformats.org/drawingml/2006/main">
-              <a:ext uri="{FF2B5EF4-FFF2-40B4-BE49-F238E27FC236}">
-                <a16:creationId xmlns:a16="http://schemas.microsoft.com/office/drawing/2014/main" id="{C9E0B98F-F4B6-49DF-AAC6-AC55923DCA44}"/>
-              </a:ext>
-            </a:extLst>
-          </p:cNvPr>
-          <p:cNvSpPr>
-            <a:spLocks xmlns:a="http://schemas.openxmlformats.org/drawingml/2006/main" noGrp="1"/>
-          </p:cNvSpPr>
-          <p:nvPr/>
-        </p:nvSpPr>
-        <p:spPr>
-          <a:xfrm xmlns:a="http://schemas.openxmlformats.org/drawingml/2006/main">
-            <a:off x="8058150" y="1524000"/>
-            <a:ext cx="3238500" cy="3714750"/>
-          </a:xfrm>
-          <a:prstGeom xmlns:a="http://schemas.openxmlformats.org/drawingml/2006/main" prst="roundRect">
-            <a:avLst>
-              <a:gd name="adj" fmla="val 3529"/>
-            </a:avLst>
-          </a:prstGeom>
-          <a:solidFill xmlns:a="http://schemas.openxmlformats.org/drawingml/2006/main">
-            <a:srgbClr val="FFFFFF"/>
-          </a:solidFill>
-          <a:ln xmlns:a="http://schemas.openxmlformats.org/drawingml/2006/main" w="9525">
-            <a:solidFill>
-              <a:srgbClr val="CBD5E1"/>
-            </a:solidFill>
-            <a:prstDash val="solid"/>
-          </a:ln>
-        </p:spPr>
-        <p:style>
-          <a:lnRef xmlns:a="http://schemas.openxmlformats.org/drawingml/2006/main" idx="0"/>
-          <a:fillRef xmlns:a="http://schemas.openxmlformats.org/drawingml/2006/main" idx="0"/>
-          <a:effectRef xmlns:a="http://schemas.openxmlformats.org/drawingml/2006/main" idx="4"/>
-          <a:fontRef xmlns:a="http://schemas.openxmlformats.org/drawingml/2006/main" idx="major"/>
-        </p:style>
-        <p:txBody xmlns:a="http://schemas.openxmlformats.org/drawingml/2006/main">
-          <a:bodyPr/>
-          <a:p/>
-        </p:txBody>
-      </p:sp>
-      <p:sp>
-        <p:nvSpPr>
-          <p:cNvPr id="34" name="">
-            <a:extLst xmlns:a="http://schemas.openxmlformats.org/drawingml/2006/main">
-              <a:ext uri="{FF2B5EF4-FFF2-40B4-BE49-F238E27FC236}">
-                <a16:creationId xmlns:a16="http://schemas.microsoft.com/office/drawing/2014/main" id="{BCC61CD5-C725-4E88-9263-4C8DCED12B4C}"/>
-              </a:ext>
-            </a:extLst>
-          </p:cNvPr>
-          <p:cNvSpPr>
-            <a:spLocks xmlns:a="http://schemas.openxmlformats.org/drawingml/2006/main" noGrp="1"/>
-          </p:cNvSpPr>
-          <p:nvPr/>
-        </p:nvSpPr>
-        <p:spPr>
-          <a:xfrm xmlns:a="http://schemas.openxmlformats.org/drawingml/2006/main">
-            <a:off x="8286750" y="1790700"/>
-            <a:ext cx="2781300" cy="247650"/>
-          </a:xfrm>
-          <a:prstGeom xmlns:a="http://schemas.openxmlformats.org/drawingml/2006/main" prst="rect">
-            <a:avLst/>
-          </a:prstGeom>
-          <a:noFill xmlns:a="http://schemas.openxmlformats.org/drawingml/2006/main"/>
-          <a:ln xmlns:a="http://schemas.openxmlformats.org/drawingml/2006/main" w="0">
-            <a:noFill/>
-            <a:prstDash val="solid"/>
-          </a:ln>
-        </p:spPr>
-        <p:txBody>
-          <a:bodyPr xmlns:a="http://schemas.openxmlformats.org/drawingml/2006/main"/>
-          <a:lstStyle xmlns:a="http://schemas.openxmlformats.org/drawingml/2006/main"/>
-          <a:p xmlns:a="http://schemas.openxmlformats.org/drawingml/2006/main">
-            <a:pPr>
-              <a:defRPr sz="1575" b="1">
-                <a:solidFill>
-                  <a:srgbClr val="F59E0B"/>
-                </a:solidFill>
-                <a:latin typeface="Aptos"/>
-                <a:ea typeface="Aptos"/>
-                <a:cs typeface="Aptos"/>
-              </a:defRPr>
-            </a:pPr>
-            <a:r>
-              <a:rPr sz="1575" b="1">
-                <a:solidFill>
-                  <a:srgbClr val="F59E0B"/>
-                </a:solidFill>
-                <a:latin typeface="Aptos"/>
-                <a:ea typeface="Aptos"/>
-                <a:cs typeface="Aptos"/>
-              </a:rPr>
-              <a:t>Gradient Boosting</a:t>
-            </a:r>
-          </a:p>
-        </p:txBody>
-      </p:sp>
-      <p:sp>
-        <p:nvSpPr>
-          <p:cNvPr id="35" name="">
-            <a:extLst xmlns:a="http://schemas.openxmlformats.org/drawingml/2006/main">
-              <a:ext uri="{FF2B5EF4-FFF2-40B4-BE49-F238E27FC236}">
-                <a16:creationId xmlns:a16="http://schemas.microsoft.com/office/drawing/2014/main" id="{0F8A5C82-B80F-4E17-8275-F64ECB7E335F}"/>
-              </a:ext>
-            </a:extLst>
-          </p:cNvPr>
-          <p:cNvSpPr>
-            <a:spLocks xmlns:a="http://schemas.openxmlformats.org/drawingml/2006/main" noGrp="1"/>
-          </p:cNvSpPr>
-          <p:nvPr/>
-        </p:nvSpPr>
-        <p:spPr>
-          <a:xfrm xmlns:a="http://schemas.openxmlformats.org/drawingml/2006/main">
-            <a:off x="8515350" y="2305050"/>
-            <a:ext cx="914400" cy="685800"/>
-          </a:xfrm>
-          <a:prstGeom xmlns:a="http://schemas.openxmlformats.org/drawingml/2006/main" prst="roundRect">
-            <a:avLst>
-              <a:gd name="adj" fmla="val 16667"/>
-            </a:avLst>
-          </a:prstGeom>
-          <a:solidFill xmlns:a="http://schemas.openxmlformats.org/drawingml/2006/main">
-            <a:srgbClr val="ECFDF5"/>
-          </a:solidFill>
-          <a:ln xmlns:a="http://schemas.openxmlformats.org/drawingml/2006/main" w="9525">
-            <a:solidFill>
-              <a:srgbClr val="99F6E4"/>
-            </a:solidFill>
-            <a:prstDash val="solid"/>
-          </a:ln>
-        </p:spPr>
-        <p:style>
-          <a:lnRef xmlns:a="http://schemas.openxmlformats.org/drawingml/2006/main" idx="0"/>
-          <a:fillRef xmlns:a="http://schemas.openxmlformats.org/drawingml/2006/main" idx="0"/>
-          <a:effectRef xmlns:a="http://schemas.openxmlformats.org/drawingml/2006/main" idx="4"/>
-          <a:fontRef xmlns:a="http://schemas.openxmlformats.org/drawingml/2006/main" idx="major"/>
-        </p:style>
-        <p:txBody xmlns:a="http://schemas.openxmlformats.org/drawingml/2006/main">
-          <a:bodyPr/>
-          <a:p/>
-        </p:txBody>
-      </p:sp>
-      <p:sp>
-        <p:nvSpPr>
-          <p:cNvPr id="36" name="">
-            <a:extLst xmlns:a="http://schemas.openxmlformats.org/drawingml/2006/main">
-              <a:ext uri="{FF2B5EF4-FFF2-40B4-BE49-F238E27FC236}">
-                <a16:creationId xmlns:a16="http://schemas.microsoft.com/office/drawing/2014/main" id="{AD4CD5B4-9846-4FDC-8794-76BB8B0E98E6}"/>
-              </a:ext>
-            </a:extLst>
-          </p:cNvPr>
-          <p:cNvSpPr>
-            <a:spLocks xmlns:a="http://schemas.openxmlformats.org/drawingml/2006/main" noGrp="1"/>
-          </p:cNvSpPr>
-          <p:nvPr/>
-        </p:nvSpPr>
-        <p:spPr>
-          <a:xfrm xmlns:a="http://schemas.openxmlformats.org/drawingml/2006/main">
-            <a:off x="8629650" y="2400300"/>
-            <a:ext cx="685800" cy="171450"/>
-          </a:xfrm>
-          <a:prstGeom xmlns:a="http://schemas.openxmlformats.org/drawingml/2006/main" prst="rect">
-            <a:avLst/>
-          </a:prstGeom>
-          <a:noFill xmlns:a="http://schemas.openxmlformats.org/drawingml/2006/main"/>
-          <a:ln xmlns:a="http://schemas.openxmlformats.org/drawingml/2006/main" w="0">
-            <a:noFill/>
-            <a:prstDash val="solid"/>
-          </a:ln>
-        </p:spPr>
-        <p:txBody>
-          <a:bodyPr xmlns:a="http://schemas.openxmlformats.org/drawingml/2006/main"/>
-          <a:lstStyle xmlns:a="http://schemas.openxmlformats.org/drawingml/2006/main"/>
-          <a:p xmlns:a="http://schemas.openxmlformats.org/drawingml/2006/main">
-            <a:pPr algn="ctr">
-              <a:defRPr sz="900" b="1">
-                <a:solidFill>
-                  <a:srgbClr val="475569"/>
-                </a:solidFill>
-                <a:latin typeface="Aptos"/>
-                <a:ea typeface="Aptos"/>
-                <a:cs typeface="Aptos"/>
-              </a:defRPr>
-            </a:pPr>
-            <a:r>
-              <a:rPr sz="900" b="1">
-                <a:solidFill>
-                  <a:srgbClr val="475569"/>
-                </a:solidFill>
-                <a:latin typeface="Aptos"/>
-                <a:ea typeface="Aptos"/>
-                <a:cs typeface="Aptos"/>
-              </a:rPr>
-              <a:t>TN</a:t>
-            </a:r>
-          </a:p>
-        </p:txBody>
-      </p:sp>
-      <p:sp>
-        <p:nvSpPr>
-          <p:cNvPr id="37" name="">
-            <a:extLst xmlns:a="http://schemas.openxmlformats.org/drawingml/2006/main">
-              <a:ext uri="{FF2B5EF4-FFF2-40B4-BE49-F238E27FC236}">
-                <a16:creationId xmlns:a16="http://schemas.microsoft.com/office/drawing/2014/main" id="{4C299A01-4C1C-4CF9-90C0-27FAFE4BDB39}"/>
-              </a:ext>
-            </a:extLst>
-          </p:cNvPr>
-          <p:cNvSpPr>
-            <a:spLocks xmlns:a="http://schemas.openxmlformats.org/drawingml/2006/main" noGrp="1"/>
-          </p:cNvSpPr>
-          <p:nvPr/>
-        </p:nvSpPr>
-        <p:spPr>
-          <a:xfrm xmlns:a="http://schemas.openxmlformats.org/drawingml/2006/main">
-            <a:off x="8629650" y="2590800"/>
-            <a:ext cx="685800" cy="285750"/>
-          </a:xfrm>
-          <a:prstGeom xmlns:a="http://schemas.openxmlformats.org/drawingml/2006/main" prst="rect">
-            <a:avLst/>
-          </a:prstGeom>
-          <a:noFill xmlns:a="http://schemas.openxmlformats.org/drawingml/2006/main"/>
-          <a:ln xmlns:a="http://schemas.openxmlformats.org/drawingml/2006/main" w="0">
-            <a:noFill/>
-            <a:prstDash val="solid"/>
-          </a:ln>
-        </p:spPr>
-        <p:txBody>
-          <a:bodyPr xmlns:a="http://schemas.openxmlformats.org/drawingml/2006/main"/>
-          <a:lstStyle xmlns:a="http://schemas.openxmlformats.org/drawingml/2006/main"/>
-          <a:p xmlns:a="http://schemas.openxmlformats.org/drawingml/2006/main">
-            <a:pPr algn="ctr">
-              <a:defRPr sz="1950" b="1">
-                <a:solidFill>
-                  <a:srgbClr val="15803D"/>
-                </a:solidFill>
-                <a:latin typeface="Aptos"/>
-                <a:ea typeface="Aptos"/>
-                <a:cs typeface="Aptos"/>
-              </a:defRPr>
-            </a:pPr>
-            <a:r>
-              <a:rPr sz="1950" b="1">
-                <a:solidFill>
-                  <a:srgbClr val="15803D"/>
-                </a:solidFill>
-                <a:latin typeface="Aptos"/>
-                <a:ea typeface="Aptos"/>
-                <a:cs typeface="Aptos"/>
-              </a:rPr>
-              <a:t>32</a:t>
-            </a:r>
-          </a:p>
-        </p:txBody>
-      </p:sp>
-      <p:sp>
-        <p:nvSpPr>
-          <p:cNvPr id="38" name="">
-            <a:extLst xmlns:a="http://schemas.openxmlformats.org/drawingml/2006/main">
-              <a:ext uri="{FF2B5EF4-FFF2-40B4-BE49-F238E27FC236}">
-                <a16:creationId xmlns:a16="http://schemas.microsoft.com/office/drawing/2014/main" id="{760447B1-3A40-496C-9956-9269EEC46EA0}"/>
-              </a:ext>
-            </a:extLst>
-          </p:cNvPr>
-          <p:cNvSpPr>
-            <a:spLocks xmlns:a="http://schemas.openxmlformats.org/drawingml/2006/main" noGrp="1"/>
-          </p:cNvSpPr>
-          <p:nvPr/>
-        </p:nvSpPr>
-        <p:spPr>
-          <a:xfrm xmlns:a="http://schemas.openxmlformats.org/drawingml/2006/main">
-            <a:off x="9620250" y="2305050"/>
-            <a:ext cx="914400" cy="685800"/>
-          </a:xfrm>
-          <a:prstGeom xmlns:a="http://schemas.openxmlformats.org/drawingml/2006/main" prst="roundRect">
-            <a:avLst>
-              <a:gd name="adj" fmla="val 16667"/>
-            </a:avLst>
-          </a:prstGeom>
-          <a:solidFill xmlns:a="http://schemas.openxmlformats.org/drawingml/2006/main">
-            <a:srgbClr val="FEF2F2"/>
-          </a:solidFill>
-          <a:ln xmlns:a="http://schemas.openxmlformats.org/drawingml/2006/main" w="9525">
-            <a:solidFill>
-              <a:srgbClr val="FECACA"/>
-            </a:solidFill>
-            <a:prstDash val="solid"/>
-          </a:ln>
-        </p:spPr>
-        <p:style>
-          <a:lnRef xmlns:a="http://schemas.openxmlformats.org/drawingml/2006/main" idx="0"/>
-          <a:fillRef xmlns:a="http://schemas.openxmlformats.org/drawingml/2006/main" idx="0"/>
-          <a:effectRef xmlns:a="http://schemas.openxmlformats.org/drawingml/2006/main" idx="4"/>
-          <a:fontRef xmlns:a="http://schemas.openxmlformats.org/drawingml/2006/main" idx="major"/>
-        </p:style>
-        <p:txBody xmlns:a="http://schemas.openxmlformats.org/drawingml/2006/main">
-          <a:bodyPr/>
-          <a:p/>
-        </p:txBody>
-      </p:sp>
-      <p:sp>
-        <p:nvSpPr>
-          <p:cNvPr id="39" name="">
-            <a:extLst xmlns:a="http://schemas.openxmlformats.org/drawingml/2006/main">
-              <a:ext uri="{FF2B5EF4-FFF2-40B4-BE49-F238E27FC236}">
-                <a16:creationId xmlns:a16="http://schemas.microsoft.com/office/drawing/2014/main" id="{E3FA1BB0-6C57-4EB8-944F-E65C8A54383C}"/>
-              </a:ext>
-            </a:extLst>
-          </p:cNvPr>
-          <p:cNvSpPr>
-            <a:spLocks xmlns:a="http://schemas.openxmlformats.org/drawingml/2006/main" noGrp="1"/>
-          </p:cNvSpPr>
-          <p:nvPr/>
-        </p:nvSpPr>
-        <p:spPr>
-          <a:xfrm xmlns:a="http://schemas.openxmlformats.org/drawingml/2006/main">
-            <a:off x="9734550" y="2400300"/>
-            <a:ext cx="685800" cy="171450"/>
-          </a:xfrm>
-          <a:prstGeom xmlns:a="http://schemas.openxmlformats.org/drawingml/2006/main" prst="rect">
-            <a:avLst/>
-          </a:prstGeom>
-          <a:noFill xmlns:a="http://schemas.openxmlformats.org/drawingml/2006/main"/>
-          <a:ln xmlns:a="http://schemas.openxmlformats.org/drawingml/2006/main" w="0">
-            <a:noFill/>
-            <a:prstDash val="solid"/>
-          </a:ln>
-        </p:spPr>
-        <p:txBody>
-          <a:bodyPr xmlns:a="http://schemas.openxmlformats.org/drawingml/2006/main"/>
-          <a:lstStyle xmlns:a="http://schemas.openxmlformats.org/drawingml/2006/main"/>
-          <a:p xmlns:a="http://schemas.openxmlformats.org/drawingml/2006/main">
-            <a:pPr algn="ctr">
-              <a:defRPr sz="900" b="1">
-                <a:solidFill>
-                  <a:srgbClr val="475569"/>
-                </a:solidFill>
-                <a:latin typeface="Aptos"/>
-                <a:ea typeface="Aptos"/>
-                <a:cs typeface="Aptos"/>
-              </a:defRPr>
-            </a:pPr>
-            <a:r>
-              <a:rPr sz="900" b="1">
-                <a:solidFill>
-                  <a:srgbClr val="475569"/>
-                </a:solidFill>
-                <a:latin typeface="Aptos"/>
-                <a:ea typeface="Aptos"/>
-                <a:cs typeface="Aptos"/>
-              </a:rPr>
-              <a:t>FP</a:t>
-            </a:r>
-          </a:p>
-        </p:txBody>
-      </p:sp>
-      <p:sp>
-        <p:nvSpPr>
-          <p:cNvPr id="40" name="">
-            <a:extLst xmlns:a="http://schemas.openxmlformats.org/drawingml/2006/main">
-              <a:ext uri="{FF2B5EF4-FFF2-40B4-BE49-F238E27FC236}">
-                <a16:creationId xmlns:a16="http://schemas.microsoft.com/office/drawing/2014/main" id="{AEFF5B1F-0A62-4215-B681-53203EB01298}"/>
-              </a:ext>
-            </a:extLst>
-          </p:cNvPr>
-          <p:cNvSpPr>
-            <a:spLocks xmlns:a="http://schemas.openxmlformats.org/drawingml/2006/main" noGrp="1"/>
-          </p:cNvSpPr>
-          <p:nvPr/>
-        </p:nvSpPr>
-        <p:spPr>
-          <a:xfrm xmlns:a="http://schemas.openxmlformats.org/drawingml/2006/main">
-            <a:off x="9734550" y="2590800"/>
-            <a:ext cx="685800" cy="285750"/>
-          </a:xfrm>
-          <a:prstGeom xmlns:a="http://schemas.openxmlformats.org/drawingml/2006/main" prst="rect">
-            <a:avLst/>
-          </a:prstGeom>
-          <a:noFill xmlns:a="http://schemas.openxmlformats.org/drawingml/2006/main"/>
-          <a:ln xmlns:a="http://schemas.openxmlformats.org/drawingml/2006/main" w="0">
-            <a:noFill/>
-            <a:prstDash val="solid"/>
-          </a:ln>
-        </p:spPr>
-        <p:txBody>
-          <a:bodyPr xmlns:a="http://schemas.openxmlformats.org/drawingml/2006/main"/>
-          <a:lstStyle xmlns:a="http://schemas.openxmlformats.org/drawingml/2006/main"/>
-          <a:p xmlns:a="http://schemas.openxmlformats.org/drawingml/2006/main">
-            <a:pPr algn="ctr">
-              <a:defRPr sz="1950" b="1">
-                <a:solidFill>
-                  <a:srgbClr val="B91C1C"/>
-                </a:solidFill>
-                <a:latin typeface="Aptos"/>
-                <a:ea typeface="Aptos"/>
-                <a:cs typeface="Aptos"/>
-              </a:defRPr>
-            </a:pPr>
-            <a:r>
-              <a:rPr sz="1950" b="1">
-                <a:solidFill>
-                  <a:srgbClr val="B91C1C"/>
-                </a:solidFill>
-                <a:latin typeface="Aptos"/>
-                <a:ea typeface="Aptos"/>
-                <a:cs typeface="Aptos"/>
-              </a:rPr>
-              <a:t>18</a:t>
-            </a:r>
-          </a:p>
-        </p:txBody>
-      </p:sp>
-      <p:sp>
-        <p:nvSpPr>
-          <p:cNvPr id="41" name="">
-            <a:extLst xmlns:a="http://schemas.openxmlformats.org/drawingml/2006/main">
-              <a:ext uri="{FF2B5EF4-FFF2-40B4-BE49-F238E27FC236}">
-                <a16:creationId xmlns:a16="http://schemas.microsoft.com/office/drawing/2014/main" id="{D5A0401D-5B2F-4421-B13D-3D4C1C7710F2}"/>
-              </a:ext>
-            </a:extLst>
-          </p:cNvPr>
-          <p:cNvSpPr>
-            <a:spLocks xmlns:a="http://schemas.openxmlformats.org/drawingml/2006/main" noGrp="1"/>
-          </p:cNvSpPr>
-          <p:nvPr/>
-        </p:nvSpPr>
-        <p:spPr>
-          <a:xfrm xmlns:a="http://schemas.openxmlformats.org/drawingml/2006/main">
-            <a:off x="8515350" y="3181350"/>
-            <a:ext cx="914400" cy="685800"/>
-          </a:xfrm>
-          <a:prstGeom xmlns:a="http://schemas.openxmlformats.org/drawingml/2006/main" prst="roundRect">
-            <a:avLst>
-              <a:gd name="adj" fmla="val 16667"/>
-            </a:avLst>
-          </a:prstGeom>
-          <a:solidFill xmlns:a="http://schemas.openxmlformats.org/drawingml/2006/main">
-            <a:srgbClr val="FEF2F2"/>
-          </a:solidFill>
-          <a:ln xmlns:a="http://schemas.openxmlformats.org/drawingml/2006/main" w="9525">
-            <a:solidFill>
-              <a:srgbClr val="FECACA"/>
-            </a:solidFill>
-            <a:prstDash val="solid"/>
-          </a:ln>
-        </p:spPr>
-        <p:style>
-          <a:lnRef xmlns:a="http://schemas.openxmlformats.org/drawingml/2006/main" idx="0"/>
-          <a:fillRef xmlns:a="http://schemas.openxmlformats.org/drawingml/2006/main" idx="0"/>
-          <a:effectRef xmlns:a="http://schemas.openxmlformats.org/drawingml/2006/main" idx="4"/>
-          <a:fontRef xmlns:a="http://schemas.openxmlformats.org/drawingml/2006/main" idx="major"/>
-        </p:style>
-        <p:txBody xmlns:a="http://schemas.openxmlformats.org/drawingml/2006/main">
-          <a:bodyPr/>
-          <a:p/>
-        </p:txBody>
-      </p:sp>
-      <p:sp>
-        <p:nvSpPr>
-          <p:cNvPr id="42" name="">
-            <a:extLst xmlns:a="http://schemas.openxmlformats.org/drawingml/2006/main">
-              <a:ext uri="{FF2B5EF4-FFF2-40B4-BE49-F238E27FC236}">
-                <a16:creationId xmlns:a16="http://schemas.microsoft.com/office/drawing/2014/main" id="{D316FAED-EEB1-48A0-9F96-2F0370A0FFCB}"/>
-              </a:ext>
-            </a:extLst>
-          </p:cNvPr>
-          <p:cNvSpPr>
-            <a:spLocks xmlns:a="http://schemas.openxmlformats.org/drawingml/2006/main" noGrp="1"/>
-          </p:cNvSpPr>
-          <p:nvPr/>
-        </p:nvSpPr>
-        <p:spPr>
-          <a:xfrm xmlns:a="http://schemas.openxmlformats.org/drawingml/2006/main">
-            <a:off x="8629650" y="3276600"/>
-            <a:ext cx="685800" cy="171450"/>
-          </a:xfrm>
-          <a:prstGeom xmlns:a="http://schemas.openxmlformats.org/drawingml/2006/main" prst="rect">
-            <a:avLst/>
-          </a:prstGeom>
-          <a:noFill xmlns:a="http://schemas.openxmlformats.org/drawingml/2006/main"/>
-          <a:ln xmlns:a="http://schemas.openxmlformats.org/drawingml/2006/main" w="0">
-            <a:noFill/>
-            <a:prstDash val="solid"/>
-          </a:ln>
-        </p:spPr>
-        <p:txBody>
-          <a:bodyPr xmlns:a="http://schemas.openxmlformats.org/drawingml/2006/main"/>
-          <a:lstStyle xmlns:a="http://schemas.openxmlformats.org/drawingml/2006/main"/>
-          <a:p xmlns:a="http://schemas.openxmlformats.org/drawingml/2006/main">
-            <a:pPr algn="ctr">
-              <a:defRPr sz="900" b="1">
-                <a:solidFill>
-                  <a:srgbClr val="475569"/>
-                </a:solidFill>
-                <a:latin typeface="Aptos"/>
-                <a:ea typeface="Aptos"/>
-                <a:cs typeface="Aptos"/>
-              </a:defRPr>
-            </a:pPr>
-            <a:r>
-              <a:rPr sz="900" b="1">
-                <a:solidFill>
-                  <a:srgbClr val="475569"/>
-                </a:solidFill>
-                <a:latin typeface="Aptos"/>
-                <a:ea typeface="Aptos"/>
-                <a:cs typeface="Aptos"/>
-              </a:rPr>
-              <a:t>FN</a:t>
-            </a:r>
-          </a:p>
-        </p:txBody>
-      </p:sp>
-      <p:sp>
-        <p:nvSpPr>
-          <p:cNvPr id="43" name="">
-            <a:extLst xmlns:a="http://schemas.openxmlformats.org/drawingml/2006/main">
-              <a:ext uri="{FF2B5EF4-FFF2-40B4-BE49-F238E27FC236}">
-                <a16:creationId xmlns:a16="http://schemas.microsoft.com/office/drawing/2014/main" id="{9DEEE1AB-F718-40F3-BD5E-5AAB78F68C6A}"/>
-              </a:ext>
-            </a:extLst>
-          </p:cNvPr>
-          <p:cNvSpPr>
-            <a:spLocks xmlns:a="http://schemas.openxmlformats.org/drawingml/2006/main" noGrp="1"/>
-          </p:cNvSpPr>
-          <p:nvPr/>
-        </p:nvSpPr>
-        <p:spPr>
-          <a:xfrm xmlns:a="http://schemas.openxmlformats.org/drawingml/2006/main">
-            <a:off x="8629650" y="3467100"/>
-            <a:ext cx="685800" cy="285750"/>
-          </a:xfrm>
-          <a:prstGeom xmlns:a="http://schemas.openxmlformats.org/drawingml/2006/main" prst="rect">
-            <a:avLst/>
-          </a:prstGeom>
-          <a:noFill xmlns:a="http://schemas.openxmlformats.org/drawingml/2006/main"/>
-          <a:ln xmlns:a="http://schemas.openxmlformats.org/drawingml/2006/main" w="0">
-            <a:noFill/>
-            <a:prstDash val="solid"/>
-          </a:ln>
-        </p:spPr>
-        <p:txBody>
-          <a:bodyPr xmlns:a="http://schemas.openxmlformats.org/drawingml/2006/main"/>
-          <a:lstStyle xmlns:a="http://schemas.openxmlformats.org/drawingml/2006/main"/>
-          <a:p xmlns:a="http://schemas.openxmlformats.org/drawingml/2006/main">
-            <a:pPr algn="ctr">
-              <a:defRPr sz="1950" b="1">
-                <a:solidFill>
-                  <a:srgbClr val="B91C1C"/>
-                </a:solidFill>
-                <a:latin typeface="Aptos"/>
-                <a:ea typeface="Aptos"/>
-                <a:cs typeface="Aptos"/>
-              </a:defRPr>
-            </a:pPr>
-            <a:r>
-              <a:rPr sz="1950" b="1">
-                <a:solidFill>
-                  <a:srgbClr val="B91C1C"/>
-                </a:solidFill>
-                <a:latin typeface="Aptos"/>
-                <a:ea typeface="Aptos"/>
-                <a:cs typeface="Aptos"/>
-              </a:rPr>
-              <a:t>14</a:t>
-            </a:r>
-          </a:p>
-        </p:txBody>
-      </p:sp>
-      <p:sp>
-        <p:nvSpPr>
-          <p:cNvPr id="44" name="">
-            <a:extLst xmlns:a="http://schemas.openxmlformats.org/drawingml/2006/main">
-              <a:ext uri="{FF2B5EF4-FFF2-40B4-BE49-F238E27FC236}">
-                <a16:creationId xmlns:a16="http://schemas.microsoft.com/office/drawing/2014/main" id="{8976C6DD-4B8A-43EF-AFDB-4E91A9BDA485}"/>
-              </a:ext>
-            </a:extLst>
-          </p:cNvPr>
-          <p:cNvSpPr>
-            <a:spLocks xmlns:a="http://schemas.openxmlformats.org/drawingml/2006/main" noGrp="1"/>
-          </p:cNvSpPr>
-          <p:nvPr/>
-        </p:nvSpPr>
-        <p:spPr>
-          <a:xfrm xmlns:a="http://schemas.openxmlformats.org/drawingml/2006/main">
-            <a:off x="9620250" y="3181350"/>
-            <a:ext cx="914400" cy="685800"/>
-          </a:xfrm>
-          <a:prstGeom xmlns:a="http://schemas.openxmlformats.org/drawingml/2006/main" prst="roundRect">
-            <a:avLst>
-              <a:gd name="adj" fmla="val 16667"/>
-            </a:avLst>
-          </a:prstGeom>
-          <a:solidFill xmlns:a="http://schemas.openxmlformats.org/drawingml/2006/main">
-            <a:srgbClr val="ECFDF5"/>
-          </a:solidFill>
-          <a:ln xmlns:a="http://schemas.openxmlformats.org/drawingml/2006/main" w="9525">
-            <a:solidFill>
-              <a:srgbClr val="99F6E4"/>
-            </a:solidFill>
-            <a:prstDash val="solid"/>
-          </a:ln>
-        </p:spPr>
-        <p:style>
-          <a:lnRef xmlns:a="http://schemas.openxmlformats.org/drawingml/2006/main" idx="0"/>
-          <a:fillRef xmlns:a="http://schemas.openxmlformats.org/drawingml/2006/main" idx="0"/>
-          <a:effectRef xmlns:a="http://schemas.openxmlformats.org/drawingml/2006/main" idx="4"/>
-          <a:fontRef xmlns:a="http://schemas.openxmlformats.org/drawingml/2006/main" idx="major"/>
-        </p:style>
-        <p:txBody xmlns:a="http://schemas.openxmlformats.org/drawingml/2006/main">
-          <a:bodyPr/>
-          <a:p/>
-        </p:txBody>
-      </p:sp>
-      <p:sp>
-        <p:nvSpPr>
-          <p:cNvPr id="45" name="">
-            <a:extLst xmlns:a="http://schemas.openxmlformats.org/drawingml/2006/main">
-              <a:ext uri="{FF2B5EF4-FFF2-40B4-BE49-F238E27FC236}">
-                <a16:creationId xmlns:a16="http://schemas.microsoft.com/office/drawing/2014/main" id="{03CE712D-BDDA-413A-8357-C4AE63491099}"/>
-              </a:ext>
-            </a:extLst>
-          </p:cNvPr>
-          <p:cNvSpPr>
-            <a:spLocks xmlns:a="http://schemas.openxmlformats.org/drawingml/2006/main" noGrp="1"/>
-          </p:cNvSpPr>
-          <p:nvPr/>
-        </p:nvSpPr>
-        <p:spPr>
-          <a:xfrm xmlns:a="http://schemas.openxmlformats.org/drawingml/2006/main">
-            <a:off x="9734550" y="3276600"/>
-            <a:ext cx="685800" cy="171450"/>
-          </a:xfrm>
-          <a:prstGeom xmlns:a="http://schemas.openxmlformats.org/drawingml/2006/main" prst="rect">
-            <a:avLst/>
-          </a:prstGeom>
-          <a:noFill xmlns:a="http://schemas.openxmlformats.org/drawingml/2006/main"/>
-          <a:ln xmlns:a="http://schemas.openxmlformats.org/drawingml/2006/main" w="0">
-            <a:noFill/>
-            <a:prstDash val="solid"/>
-          </a:ln>
-        </p:spPr>
-        <p:txBody>
-          <a:bodyPr xmlns:a="http://schemas.openxmlformats.org/drawingml/2006/main"/>
-          <a:lstStyle xmlns:a="http://schemas.openxmlformats.org/drawingml/2006/main"/>
-          <a:p xmlns:a="http://schemas.openxmlformats.org/drawingml/2006/main">
-            <a:pPr algn="ctr">
-              <a:defRPr sz="900" b="1">
-                <a:solidFill>
-                  <a:srgbClr val="475569"/>
-                </a:solidFill>
-                <a:latin typeface="Aptos"/>
-                <a:ea typeface="Aptos"/>
-                <a:cs typeface="Aptos"/>
-              </a:defRPr>
-            </a:pPr>
-            <a:r>
-              <a:rPr sz="900" b="1">
-                <a:solidFill>
-                  <a:srgbClr val="475569"/>
-                </a:solidFill>
-                <a:latin typeface="Aptos"/>
-                <a:ea typeface="Aptos"/>
-                <a:cs typeface="Aptos"/>
-              </a:rPr>
-              <a:t>TP</a:t>
-            </a:r>
-          </a:p>
-        </p:txBody>
-      </p:sp>
-      <p:sp>
-        <p:nvSpPr>
-          <p:cNvPr id="46" name="">
-            <a:extLst xmlns:a="http://schemas.openxmlformats.org/drawingml/2006/main">
-              <a:ext uri="{FF2B5EF4-FFF2-40B4-BE49-F238E27FC236}">
-                <a16:creationId xmlns:a16="http://schemas.microsoft.com/office/drawing/2014/main" id="{B60EBC86-7980-4EF5-BE5F-455EBC8A2948}"/>
-              </a:ext>
-            </a:extLst>
-          </p:cNvPr>
-          <p:cNvSpPr>
-            <a:spLocks xmlns:a="http://schemas.openxmlformats.org/drawingml/2006/main" noGrp="1"/>
-          </p:cNvSpPr>
-          <p:nvPr/>
-        </p:nvSpPr>
-        <p:spPr>
-          <a:xfrm xmlns:a="http://schemas.openxmlformats.org/drawingml/2006/main">
-            <a:off x="9734550" y="3467100"/>
-            <a:ext cx="685800" cy="285750"/>
-          </a:xfrm>
-          <a:prstGeom xmlns:a="http://schemas.openxmlformats.org/drawingml/2006/main" prst="rect">
-            <a:avLst/>
-          </a:prstGeom>
-          <a:noFill xmlns:a="http://schemas.openxmlformats.org/drawingml/2006/main"/>
-          <a:ln xmlns:a="http://schemas.openxmlformats.org/drawingml/2006/main" w="0">
-            <a:noFill/>
-            <a:prstDash val="solid"/>
-          </a:ln>
-        </p:spPr>
-        <p:txBody>
-          <a:bodyPr xmlns:a="http://schemas.openxmlformats.org/drawingml/2006/main"/>
-          <a:lstStyle xmlns:a="http://schemas.openxmlformats.org/drawingml/2006/main"/>
-          <a:p xmlns:a="http://schemas.openxmlformats.org/drawingml/2006/main">
-            <a:pPr algn="ctr">
-              <a:defRPr sz="1950" b="1">
-                <a:solidFill>
-                  <a:srgbClr val="15803D"/>
-                </a:solidFill>
-                <a:latin typeface="Aptos"/>
-                <a:ea typeface="Aptos"/>
-                <a:cs typeface="Aptos"/>
-              </a:defRPr>
-            </a:pPr>
-            <a:r>
-              <a:rPr sz="1950" b="1">
-                <a:solidFill>
-                  <a:srgbClr val="15803D"/>
-                </a:solidFill>
-                <a:latin typeface="Aptos"/>
-                <a:ea typeface="Aptos"/>
-                <a:cs typeface="Aptos"/>
-              </a:rPr>
-              <a:t>36</a:t>
-            </a:r>
-          </a:p>
-        </p:txBody>
-      </p:sp>
-      <p:sp>
-        <p:nvSpPr>
-          <p:cNvPr id="47" name="">
-            <a:extLst xmlns:a="http://schemas.openxmlformats.org/drawingml/2006/main">
-              <a:ext uri="{FF2B5EF4-FFF2-40B4-BE49-F238E27FC236}">
-                <a16:creationId xmlns:a16="http://schemas.microsoft.com/office/drawing/2014/main" id="{A03449F3-378E-48B7-9910-EAB1D0456001}"/>
-              </a:ext>
-            </a:extLst>
-          </p:cNvPr>
-          <p:cNvSpPr>
-            <a:spLocks xmlns:a="http://schemas.openxmlformats.org/drawingml/2006/main" noGrp="1"/>
-          </p:cNvSpPr>
-          <p:nvPr/>
-        </p:nvSpPr>
-        <p:spPr>
-          <a:xfrm xmlns:a="http://schemas.openxmlformats.org/drawingml/2006/main">
-            <a:off x="8324850" y="4229100"/>
-            <a:ext cx="2705100" cy="552450"/>
-          </a:xfrm>
-          <a:prstGeom xmlns:a="http://schemas.openxmlformats.org/drawingml/2006/main" prst="rect">
-            <a:avLst/>
-          </a:prstGeom>
-          <a:noFill xmlns:a="http://schemas.openxmlformats.org/drawingml/2006/main"/>
-          <a:ln xmlns:a="http://schemas.openxmlformats.org/drawingml/2006/main" w="0">
-            <a:noFill/>
-            <a:prstDash val="solid"/>
-          </a:ln>
-        </p:spPr>
-        <p:txBody>
-          <a:bodyPr xmlns:a="http://schemas.openxmlformats.org/drawingml/2006/main"/>
-          <a:lstStyle xmlns:a="http://schemas.openxmlformats.org/drawingml/2006/main"/>
-          <a:p xmlns:a="http://schemas.openxmlformats.org/drawingml/2006/main">
-            <a:pPr>
-              <a:defRPr sz="1125">
-                <a:solidFill>
-                  <a:srgbClr val="475569"/>
-                </a:solidFill>
-                <a:latin typeface="Aptos"/>
-                <a:ea typeface="Aptos"/>
-                <a:cs typeface="Aptos"/>
-              </a:defRPr>
-            </a:pPr>
-            <a:r>
-              <a:rPr sz="1125">
-                <a:solidFill>
-                  <a:srgbClr val="475569"/>
-                </a:solidFill>
-                <a:latin typeface="Aptos"/>
-                <a:ea typeface="Aptos"/>
-                <a:cs typeface="Aptos"/>
-              </a:rPr>
-              <a:t>FP en düşük; RF'e yakın ama doğru sınıfta biraz daha fazla kaçırıyor.</a:t>
-            </a:r>
-          </a:p>
-        </p:txBody>
-      </p:sp>
-      <p:sp>
-        <p:nvSpPr>
-          <p:cNvPr id="48" name="">
-            <a:extLst xmlns:a="http://schemas.openxmlformats.org/drawingml/2006/main">
-              <a:ext uri="{FF2B5EF4-FFF2-40B4-BE49-F238E27FC236}">
-                <a16:creationId xmlns:a16="http://schemas.microsoft.com/office/drawing/2014/main" id="{D5EAF6E0-9556-4BE6-A5EC-702ED67A82B5}"/>
-              </a:ext>
-            </a:extLst>
-          </p:cNvPr>
-          <p:cNvSpPr>
-            <a:spLocks xmlns:a="http://schemas.openxmlformats.org/drawingml/2006/main" noGrp="1"/>
-          </p:cNvSpPr>
-          <p:nvPr/>
-        </p:nvSpPr>
-        <p:spPr>
-          <a:xfrm xmlns:a="http://schemas.openxmlformats.org/drawingml/2006/main">
-            <a:off x="685800" y="6496050"/>
-            <a:ext cx="5905500" cy="171450"/>
-          </a:xfrm>
-          <a:prstGeom xmlns:a="http://schemas.openxmlformats.org/drawingml/2006/main" prst="rect">
-            <a:avLst/>
-          </a:prstGeom>
-          <a:noFill xmlns:a="http://schemas.openxmlformats.org/drawingml/2006/main"/>
-          <a:ln xmlns:a="http://schemas.openxmlformats.org/drawingml/2006/main" w="0">
-            <a:noFill/>
-            <a:prstDash val="solid"/>
-          </a:ln>
-        </p:spPr>
-        <p:txBody>
-          <a:bodyPr xmlns:a="http://schemas.openxmlformats.org/drawingml/2006/main"/>
-          <a:lstStyle xmlns:a="http://schemas.openxmlformats.org/drawingml/2006/main"/>
-          <a:p xmlns:a="http://schemas.openxmlformats.org/drawingml/2006/main">
-            <a:pPr>
-              <a:defRPr sz="825">
-                <a:solidFill>
-                  <a:srgbClr val="64748B"/>
-                </a:solidFill>
-                <a:latin typeface="Aptos"/>
-                <a:ea typeface="Aptos"/>
-                <a:cs typeface="Aptos"/>
-              </a:defRPr>
-            </a:pPr>
-            <a:r>
-              <a:rPr sz="825">
-                <a:solidFill>
-                  <a:srgbClr val="64748B"/>
-                </a:solidFill>
-                <a:latin typeface="Aptos"/>
-                <a:ea typeface="Aptos"/>
-                <a:cs typeface="Aptos"/>
-              </a:rPr>
-              <a:t>Cosmos-T1 top1-top2 güven sinyali  ·  Betül Arslan</a:t>
-            </a:r>
-          </a:p>
-        </p:txBody>
-      </p:sp>
-      <p:sp>
-        <p:nvSpPr>
-          <p:cNvPr id="49" name="">
-            <a:extLst xmlns:a="http://schemas.openxmlformats.org/drawingml/2006/main">
-              <a:ext uri="{FF2B5EF4-FFF2-40B4-BE49-F238E27FC236}">
-                <a16:creationId xmlns:a16="http://schemas.microsoft.com/office/drawing/2014/main" id="{4224BDB9-B35E-4E02-8207-01D206B5807C}"/>
-              </a:ext>
-            </a:extLst>
-          </p:cNvPr>
-          <p:cNvSpPr>
-            <a:spLocks xmlns:a="http://schemas.openxmlformats.org/drawingml/2006/main" noGrp="1"/>
-          </p:cNvSpPr>
-          <p:nvPr/>
-        </p:nvSpPr>
-        <p:spPr>
-          <a:xfrm xmlns:a="http://schemas.openxmlformats.org/drawingml/2006/main">
-            <a:off x="11201400" y="6496050"/>
-            <a:ext cx="304800" cy="171450"/>
-          </a:xfrm>
-          <a:prstGeom xmlns:a="http://schemas.openxmlformats.org/drawingml/2006/main" prst="rect">
-            <a:avLst/>
-          </a:prstGeom>
-          <a:noFill xmlns:a="http://schemas.openxmlformats.org/drawingml/2006/main"/>
-          <a:ln xmlns:a="http://schemas.openxmlformats.org/drawingml/2006/main" w="0">
-            <a:noFill/>
-            <a:prstDash val="solid"/>
-          </a:ln>
-        </p:spPr>
-        <p:txBody>
-          <a:bodyPr xmlns:a="http://schemas.openxmlformats.org/drawingml/2006/main"/>
-          <a:lstStyle xmlns:a="http://schemas.openxmlformats.org/drawingml/2006/main"/>
-          <a:p xmlns:a="http://schemas.openxmlformats.org/drawingml/2006/main">
             <a:pPr algn="r">
               <a:defRPr sz="825" b="1">
                 <a:solidFill>
@@ -15023,7 +12670,7 @@
                 <a:ea typeface="Aptos"/>
                 <a:cs typeface="Aptos"/>
               </a:rPr>
-              <a:t>011</a:t>
+              <a:t>07</a:t>
             </a:r>
           </a:p>
         </p:txBody>
@@ -15044,8 +12691,8 @@
         </p:blipFill>
         <p:spPr>
           <a:xfrm>
-            <a:off x="274320" y="1920240"/>
-            <a:ext cx="8595360" cy="2643249"/>
+            <a:off x="274320" y="1463040"/>
+            <a:ext cx="11612880" cy="3571198"/>
           </a:xfrm>
           <a:prstGeom prst="rect">
             <a:avLst/>
@@ -15188,90 +12835,29 @@
                 <a:ea typeface="Aptos"/>
                 <a:cs typeface="Aptos"/>
               </a:rPr>
-              <a:t>Tüm modeller 0.115 üstünde AUC verdi; RF en yüksek değere ulaştı.</a:t>
-            </a:r>
-          </a:p>
-        </p:txBody>
-      </p:sp>
-      <p:graphicFrame>
-        <p:nvGraphicFramePr>
-          <p:cNvPr id="12" name="Chart"/>
-          <p:cNvGraphicFramePr/>
-          <p:nvPr/>
-        </p:nvGraphicFramePr>
-        <p:xfrm>
-          <a:off xmlns:a="http://schemas.openxmlformats.org/drawingml/2006/main" x="914400" y="1504950"/>
-          <a:ext xmlns:a="http://schemas.openxmlformats.org/drawingml/2006/main" cx="6096000" cy="3429000"/>
-        </p:xfrm>
-        <a:graphic xmlns:a="http://schemas.openxmlformats.org/drawingml/2006/main">
-          <a:graphicData uri="http://schemas.openxmlformats.org/drawingml/2006/chart">
-            <c:chart xmlns:r="http://schemas.openxmlformats.org/officeDocument/2006/relationships" xmlns:c="http://schemas.openxmlformats.org/drawingml/2006/chart" r:id="R853e115f7da04d48"/>
-          </a:graphicData>
-        </a:graphic>
-      </p:graphicFrame>
-      <p:sp>
-        <p:nvSpPr>
-          <p:cNvPr id="4" name="">
-            <a:extLst xmlns:a="http://schemas.openxmlformats.org/drawingml/2006/main">
-              <a:ext uri="{FF2B5EF4-FFF2-40B4-BE49-F238E27FC236}">
-                <a16:creationId xmlns:a16="http://schemas.microsoft.com/office/drawing/2014/main" id="{2FB75EC6-3CA9-4631-B401-BA022B7DE3D6}"/>
-              </a:ext>
-            </a:extLst>
-          </p:cNvPr>
-          <p:cNvSpPr>
-            <a:spLocks xmlns:a="http://schemas.openxmlformats.org/drawingml/2006/main" noGrp="1"/>
-          </p:cNvSpPr>
-          <p:nvPr/>
-        </p:nvSpPr>
-        <p:spPr>
-          <a:xfrm xmlns:a="http://schemas.openxmlformats.org/drawingml/2006/main">
-            <a:off x="7620000" y="1695450"/>
-            <a:ext cx="3143250" cy="2857500"/>
-          </a:xfrm>
-          <a:prstGeom xmlns:a="http://schemas.openxmlformats.org/drawingml/2006/main" prst="roundRect">
-            <a:avLst>
-              <a:gd name="adj" fmla="val 4000"/>
-            </a:avLst>
-          </a:prstGeom>
-          <a:solidFill xmlns:a="http://schemas.openxmlformats.org/drawingml/2006/main">
-            <a:srgbClr val="EFF6FF"/>
-          </a:solidFill>
-          <a:ln xmlns:a="http://schemas.openxmlformats.org/drawingml/2006/main" w="9525">
-            <a:solidFill>
-              <a:srgbClr val="BFDBFE"/>
-            </a:solidFill>
-            <a:prstDash val="solid"/>
-          </a:ln>
-        </p:spPr>
-        <p:style>
-          <a:lnRef xmlns:a="http://schemas.openxmlformats.org/drawingml/2006/main" idx="0"/>
-          <a:fillRef xmlns:a="http://schemas.openxmlformats.org/drawingml/2006/main" idx="0"/>
-          <a:effectRef xmlns:a="http://schemas.openxmlformats.org/drawingml/2006/main" idx="4"/>
-          <a:fontRef xmlns:a="http://schemas.openxmlformats.org/drawingml/2006/main" idx="major"/>
-        </p:style>
-        <p:txBody xmlns:a="http://schemas.openxmlformats.org/drawingml/2006/main">
-          <a:bodyPr/>
-          <a:p/>
-        </p:txBody>
-      </p:sp>
-      <p:sp>
-        <p:nvSpPr>
-          <p:cNvPr id="5" name="">
-            <a:extLst xmlns:a="http://schemas.openxmlformats.org/drawingml/2006/main">
-              <a:ext uri="{FF2B5EF4-FFF2-40B4-BE49-F238E27FC236}">
-                <a16:creationId xmlns:a16="http://schemas.microsoft.com/office/drawing/2014/main" id="{74042521-D482-482D-B164-7C49D5A36F65}"/>
-              </a:ext>
-            </a:extLst>
-          </p:cNvPr>
-          <p:cNvSpPr>
-            <a:spLocks xmlns:a="http://schemas.openxmlformats.org/drawingml/2006/main" noGrp="1"/>
-          </p:cNvSpPr>
-          <p:nvPr/>
-        </p:nvSpPr>
-        <p:spPr>
-          <a:xfrm xmlns:a="http://schemas.openxmlformats.org/drawingml/2006/main">
-            <a:off x="7886700" y="2000250"/>
-            <a:ext cx="2381250" cy="285750"/>
+              <a:t>F1'de RF (0.743), AUC'de GB (0.794) öne çıktı.</a:t>
+            </a:r>
+          </a:p>
+        </p:txBody>
+      </p:sp>
+      <p:sp>
+        <p:nvSpPr>
+          <p:cNvPr id="8" name="">
+            <a:extLst xmlns:a="http://schemas.openxmlformats.org/drawingml/2006/main">
+              <a:ext uri="{FF2B5EF4-FFF2-40B4-BE49-F238E27FC236}">
+                <a16:creationId xmlns:a16="http://schemas.microsoft.com/office/drawing/2014/main" id="{86A2C973-58E6-43FF-8EB8-D4E2B8DDE3E7}"/>
+              </a:ext>
+            </a:extLst>
+          </p:cNvPr>
+          <p:cNvSpPr>
+            <a:spLocks xmlns:a="http://schemas.openxmlformats.org/drawingml/2006/main" noGrp="1"/>
+          </p:cNvSpPr>
+          <p:nvPr/>
+        </p:nvSpPr>
+        <p:spPr>
+          <a:xfrm xmlns:a="http://schemas.openxmlformats.org/drawingml/2006/main">
+            <a:off x="685800" y="6496050"/>
+            <a:ext cx="5905500" cy="171450"/>
           </a:xfrm>
           <a:prstGeom xmlns:a="http://schemas.openxmlformats.org/drawingml/2006/main" prst="rect">
             <a:avLst/>
@@ -15287,47 +12873,47 @@
           <a:lstStyle xmlns:a="http://schemas.openxmlformats.org/drawingml/2006/main"/>
           <a:p xmlns:a="http://schemas.openxmlformats.org/drawingml/2006/main">
             <a:pPr>
-              <a:defRPr sz="1800" b="1">
-                <a:solidFill>
-                  <a:srgbClr val="1D4ED8"/>
-                </a:solidFill>
-                <a:latin typeface="Aptos"/>
-                <a:ea typeface="Aptos"/>
-                <a:cs typeface="Aptos"/>
-              </a:defRPr>
-            </a:pPr>
-            <a:r>
-              <a:rPr sz="1800" b="1">
-                <a:solidFill>
-                  <a:srgbClr val="1D4ED8"/>
-                </a:solidFill>
-                <a:latin typeface="Aptos"/>
-                <a:ea typeface="Aptos"/>
-                <a:cs typeface="Aptos"/>
-              </a:rPr>
-              <a:t>Model seçimi</a:t>
-            </a:r>
-          </a:p>
-        </p:txBody>
-      </p:sp>
-      <p:sp>
-        <p:nvSpPr>
-          <p:cNvPr id="6" name="">
-            <a:extLst xmlns:a="http://schemas.openxmlformats.org/drawingml/2006/main">
-              <a:ext uri="{FF2B5EF4-FFF2-40B4-BE49-F238E27FC236}">
-                <a16:creationId xmlns:a16="http://schemas.microsoft.com/office/drawing/2014/main" id="{3240005D-2D00-450E-963F-05EC6000331F}"/>
-              </a:ext>
-            </a:extLst>
-          </p:cNvPr>
-          <p:cNvSpPr>
-            <a:spLocks xmlns:a="http://schemas.openxmlformats.org/drawingml/2006/main" noGrp="1"/>
-          </p:cNvSpPr>
-          <p:nvPr/>
-        </p:nvSpPr>
-        <p:spPr>
-          <a:xfrm xmlns:a="http://schemas.openxmlformats.org/drawingml/2006/main">
-            <a:off x="7924800" y="2552700"/>
-            <a:ext cx="2333625" cy="1219200"/>
+              <a:defRPr sz="825">
+                <a:solidFill>
+                  <a:srgbClr val="64748B"/>
+                </a:solidFill>
+                <a:latin typeface="Aptos"/>
+                <a:ea typeface="Aptos"/>
+                <a:cs typeface="Aptos"/>
+              </a:defRPr>
+            </a:pPr>
+            <a:r>
+              <a:rPr sz="825">
+                <a:solidFill>
+                  <a:srgbClr val="64748B"/>
+                </a:solidFill>
+                <a:latin typeface="Aptos"/>
+                <a:ea typeface="Aptos"/>
+                <a:cs typeface="Aptos"/>
+              </a:rPr>
+              <a:t>Cosmos-T1 top1-top2 güven sinyali  ·  Betül Arslan</a:t>
+            </a:r>
+          </a:p>
+        </p:txBody>
+      </p:sp>
+      <p:sp>
+        <p:nvSpPr>
+          <p:cNvPr id="9" name="">
+            <a:extLst xmlns:a="http://schemas.openxmlformats.org/drawingml/2006/main">
+              <a:ext uri="{FF2B5EF4-FFF2-40B4-BE49-F238E27FC236}">
+                <a16:creationId xmlns:a16="http://schemas.microsoft.com/office/drawing/2014/main" id="{20ED9217-CB7B-40CF-B183-57F01840F532}"/>
+              </a:ext>
+            </a:extLst>
+          </p:cNvPr>
+          <p:cNvSpPr>
+            <a:spLocks xmlns:a="http://schemas.openxmlformats.org/drawingml/2006/main" noGrp="1"/>
+          </p:cNvSpPr>
+          <p:nvPr/>
+        </p:nvSpPr>
+        <p:spPr>
+          <a:xfrm xmlns:a="http://schemas.openxmlformats.org/drawingml/2006/main">
+            <a:off x="11201400" y="6496050"/>
+            <a:ext cx="304800" cy="171450"/>
           </a:xfrm>
           <a:prstGeom xmlns:a="http://schemas.openxmlformats.org/drawingml/2006/main" prst="rect">
             <a:avLst/>
@@ -15342,220 +12928,6 @@
           <a:bodyPr xmlns:a="http://schemas.openxmlformats.org/drawingml/2006/main"/>
           <a:lstStyle xmlns:a="http://schemas.openxmlformats.org/drawingml/2006/main"/>
           <a:p xmlns:a="http://schemas.openxmlformats.org/drawingml/2006/main">
-            <a:pPr>
-              <a:defRPr sz="1200">
-                <a:solidFill>
-                  <a:srgbClr val="0F172A"/>
-                </a:solidFill>
-                <a:latin typeface="Aptos"/>
-                <a:ea typeface="Aptos"/>
-                <a:cs typeface="Aptos"/>
-              </a:defRPr>
-            </a:pPr>
-            <a:r>
-              <a:rPr sz="1200">
-                <a:solidFill>
-                  <a:srgbClr val="0F172A"/>
-                </a:solidFill>
-                <a:latin typeface="Aptos"/>
-                <a:ea typeface="Aptos"/>
-                <a:cs typeface="Aptos"/>
-              </a:rPr>
-              <a:t>• RF, F1 ve ROC-AUC metriklerinde lider.</a:t>
-            </a:r>
-          </a:p>
-          <a:p xmlns:a="http://schemas.openxmlformats.org/drawingml/2006/main">
-            <a:pPr>
-              <a:defRPr sz="1200">
-                <a:solidFill>
-                  <a:srgbClr val="0F172A"/>
-                </a:solidFill>
-                <a:latin typeface="Aptos"/>
-                <a:ea typeface="Aptos"/>
-                <a:cs typeface="Aptos"/>
-              </a:defRPr>
-            </a:pPr>
-            <a:r>
-              <a:rPr sz="1200">
-                <a:solidFill>
-                  <a:srgbClr val="0F172A"/>
-                </a:solidFill>
-                <a:latin typeface="Aptos"/>
-                <a:ea typeface="Aptos"/>
-                <a:cs typeface="Aptos"/>
-              </a:rPr>
-              <a:t>• GB çok yakın; ancak RF recall tarafında daha avantajlı.</a:t>
-            </a:r>
-          </a:p>
-          <a:p xmlns:a="http://schemas.openxmlformats.org/drawingml/2006/main">
-            <a:pPr>
-              <a:defRPr sz="1200">
-                <a:solidFill>
-                  <a:srgbClr val="0F172A"/>
-                </a:solidFill>
-                <a:latin typeface="Aptos"/>
-                <a:ea typeface="Aptos"/>
-                <a:cs typeface="Aptos"/>
-              </a:defRPr>
-            </a:pPr>
-            <a:r>
-              <a:rPr sz="1200">
-                <a:solidFill>
-                  <a:srgbClr val="0F172A"/>
-                </a:solidFill>
-                <a:latin typeface="Aptos"/>
-                <a:ea typeface="Aptos"/>
-                <a:cs typeface="Aptos"/>
-              </a:rPr>
-              <a:t>• LR sinyal görüyor ama etkileşimleri yakalamakta zayıf kalıyor.</a:t>
-            </a:r>
-          </a:p>
-        </p:txBody>
-      </p:sp>
-      <p:sp>
-        <p:nvSpPr>
-          <p:cNvPr id="7" name="">
-            <a:extLst xmlns:a="http://schemas.openxmlformats.org/drawingml/2006/main">
-              <a:ext uri="{FF2B5EF4-FFF2-40B4-BE49-F238E27FC236}">
-                <a16:creationId xmlns:a16="http://schemas.microsoft.com/office/drawing/2014/main" id="{42AAF099-F0DE-4AB3-A1AC-C4892D7280CA}"/>
-              </a:ext>
-            </a:extLst>
-          </p:cNvPr>
-          <p:cNvSpPr>
-            <a:spLocks xmlns:a="http://schemas.openxmlformats.org/drawingml/2006/main" noGrp="1"/>
-          </p:cNvSpPr>
-          <p:nvPr/>
-        </p:nvSpPr>
-        <p:spPr>
-          <a:xfrm xmlns:a="http://schemas.openxmlformats.org/drawingml/2006/main">
-            <a:off x="7886700" y="3962400"/>
-            <a:ext cx="2476500" cy="457200"/>
-          </a:xfrm>
-          <a:prstGeom xmlns:a="http://schemas.openxmlformats.org/drawingml/2006/main" prst="rect">
-            <a:avLst/>
-          </a:prstGeom>
-          <a:noFill xmlns:a="http://schemas.openxmlformats.org/drawingml/2006/main"/>
-          <a:ln xmlns:a="http://schemas.openxmlformats.org/drawingml/2006/main" w="0">
-            <a:noFill/>
-            <a:prstDash val="solid"/>
-          </a:ln>
-        </p:spPr>
-        <p:txBody>
-          <a:bodyPr xmlns:a="http://schemas.openxmlformats.org/drawingml/2006/main"/>
-          <a:lstStyle xmlns:a="http://schemas.openxmlformats.org/drawingml/2006/main"/>
-          <a:p xmlns:a="http://schemas.openxmlformats.org/drawingml/2006/main">
-            <a:pPr>
-              <a:defRPr sz="1050">
-                <a:solidFill>
-                  <a:srgbClr val="475569"/>
-                </a:solidFill>
-                <a:latin typeface="Aptos"/>
-                <a:ea typeface="Aptos"/>
-                <a:cs typeface="Aptos"/>
-              </a:defRPr>
-            </a:pPr>
-            <a:r>
-              <a:rPr sz="1050">
-                <a:solidFill>
-                  <a:srgbClr val="475569"/>
-                </a:solidFill>
-                <a:latin typeface="Aptos"/>
-                <a:ea typeface="Aptos"/>
-                <a:cs typeface="Aptos"/>
-              </a:rPr>
-              <a:t>Final sonuç: 1000+100 dengeli sette RF F1=0.7429, GB AUC=0.7936 ile en iyi AUC sağladı.</a:t>
-            </a:r>
-          </a:p>
-        </p:txBody>
-      </p:sp>
-      <p:sp>
-        <p:nvSpPr>
-          <p:cNvPr id="8" name="">
-            <a:extLst xmlns:a="http://schemas.openxmlformats.org/drawingml/2006/main">
-              <a:ext uri="{FF2B5EF4-FFF2-40B4-BE49-F238E27FC236}">
-                <a16:creationId xmlns:a16="http://schemas.microsoft.com/office/drawing/2014/main" id="{86A2C973-58E6-43FF-8EB8-D4E2B8DDE3E7}"/>
-              </a:ext>
-            </a:extLst>
-          </p:cNvPr>
-          <p:cNvSpPr>
-            <a:spLocks xmlns:a="http://schemas.openxmlformats.org/drawingml/2006/main" noGrp="1"/>
-          </p:cNvSpPr>
-          <p:nvPr/>
-        </p:nvSpPr>
-        <p:spPr>
-          <a:xfrm xmlns:a="http://schemas.openxmlformats.org/drawingml/2006/main">
-            <a:off x="685800" y="6496050"/>
-            <a:ext cx="5905500" cy="171450"/>
-          </a:xfrm>
-          <a:prstGeom xmlns:a="http://schemas.openxmlformats.org/drawingml/2006/main" prst="rect">
-            <a:avLst/>
-          </a:prstGeom>
-          <a:noFill xmlns:a="http://schemas.openxmlformats.org/drawingml/2006/main"/>
-          <a:ln xmlns:a="http://schemas.openxmlformats.org/drawingml/2006/main" w="0">
-            <a:noFill/>
-            <a:prstDash val="solid"/>
-          </a:ln>
-        </p:spPr>
-        <p:txBody>
-          <a:bodyPr xmlns:a="http://schemas.openxmlformats.org/drawingml/2006/main"/>
-          <a:lstStyle xmlns:a="http://schemas.openxmlformats.org/drawingml/2006/main"/>
-          <a:p xmlns:a="http://schemas.openxmlformats.org/drawingml/2006/main">
-            <a:pPr>
-              <a:defRPr sz="825">
-                <a:solidFill>
-                  <a:srgbClr val="64748B"/>
-                </a:solidFill>
-                <a:latin typeface="Aptos"/>
-                <a:ea typeface="Aptos"/>
-                <a:cs typeface="Aptos"/>
-              </a:defRPr>
-            </a:pPr>
-            <a:r>
-              <a:rPr sz="825">
-                <a:solidFill>
-                  <a:srgbClr val="64748B"/>
-                </a:solidFill>
-                <a:latin typeface="Aptos"/>
-                <a:ea typeface="Aptos"/>
-                <a:cs typeface="Aptos"/>
-              </a:rPr>
-              <a:t>Cosmos-T1 top1-top2 güven sinyali  ·  Betül Arslan</a:t>
-            </a:r>
-          </a:p>
-        </p:txBody>
-      </p:sp>
-      <p:sp>
-        <p:nvSpPr>
-          <p:cNvPr id="9" name="">
-            <a:extLst xmlns:a="http://schemas.openxmlformats.org/drawingml/2006/main">
-              <a:ext uri="{FF2B5EF4-FFF2-40B4-BE49-F238E27FC236}">
-                <a16:creationId xmlns:a16="http://schemas.microsoft.com/office/drawing/2014/main" id="{20ED9217-CB7B-40CF-B183-57F01840F532}"/>
-              </a:ext>
-            </a:extLst>
-          </p:cNvPr>
-          <p:cNvSpPr>
-            <a:spLocks xmlns:a="http://schemas.openxmlformats.org/drawingml/2006/main" noGrp="1"/>
-          </p:cNvSpPr>
-          <p:nvPr/>
-        </p:nvSpPr>
-        <p:spPr>
-          <a:xfrm xmlns:a="http://schemas.openxmlformats.org/drawingml/2006/main">
-            <a:off x="11201400" y="6496050"/>
-            <a:ext cx="304800" cy="171450"/>
-          </a:xfrm>
-          <a:prstGeom xmlns:a="http://schemas.openxmlformats.org/drawingml/2006/main" prst="rect">
-            <a:avLst/>
-          </a:prstGeom>
-          <a:noFill xmlns:a="http://schemas.openxmlformats.org/drawingml/2006/main"/>
-          <a:ln xmlns:a="http://schemas.openxmlformats.org/drawingml/2006/main" w="0">
-            <a:noFill/>
-            <a:prstDash val="solid"/>
-          </a:ln>
-        </p:spPr>
-        <p:txBody>
-          <a:bodyPr xmlns:a="http://schemas.openxmlformats.org/drawingml/2006/main"/>
-          <a:lstStyle xmlns:a="http://schemas.openxmlformats.org/drawingml/2006/main"/>
-          <a:p xmlns:a="http://schemas.openxmlformats.org/drawingml/2006/main">
             <a:pPr algn="r">
               <a:defRPr sz="825" b="1">
                 <a:solidFill>
@@ -15582,7 +12954,7 @@
       </p:sp>
       <p:pic xmlns:a="http://schemas.openxmlformats.org/drawingml/2006/main" xmlns:r="http://schemas.openxmlformats.org/officeDocument/2006/relationships">
         <p:nvPicPr>
-          <p:cNvPr id="13" name="Picture 12" descr="fig_roc.png"/>
+          <p:cNvPr id="10" name="Picture 9" descr="fig_roc.png"/>
           <p:cNvPicPr>
             <a:picLocks noChangeAspect="1"/>
           </p:cNvPicPr>
@@ -15596,8 +12968,8 @@
         </p:blipFill>
         <p:spPr>
           <a:xfrm>
-            <a:off x="4389120" y="1645920"/>
-            <a:ext cx="4572000" cy="3909391"/>
+            <a:off x="274320" y="1463040"/>
+            <a:ext cx="11612880" cy="9929854"/>
           </a:xfrm>
           <a:prstGeom prst="rect">
             <a:avLst/>
@@ -15745,85 +13117,24 @@
           </a:p>
         </p:txBody>
       </p:sp>
-      <p:graphicFrame>
-        <p:nvGraphicFramePr>
-          <p:cNvPr id="20" name="Chart"/>
-          <p:cNvGraphicFramePr/>
-          <p:nvPr/>
-        </p:nvGraphicFramePr>
-        <p:xfrm>
-          <a:off xmlns:a="http://schemas.openxmlformats.org/drawingml/2006/main" x="838200" y="1504950"/>
-          <a:ext xmlns:a="http://schemas.openxmlformats.org/drawingml/2006/main" cx="6096000" cy="3429000"/>
-        </p:xfrm>
-        <a:graphic xmlns:a="http://schemas.openxmlformats.org/drawingml/2006/main">
-          <a:graphicData uri="http://schemas.openxmlformats.org/drawingml/2006/chart">
-            <c:chart xmlns:r="http://schemas.openxmlformats.org/officeDocument/2006/relationships" xmlns:c="http://schemas.openxmlformats.org/drawingml/2006/chart" r:id="R0ae9a88d8b87425d"/>
-          </a:graphicData>
-        </a:graphic>
-      </p:graphicFrame>
-      <p:sp>
-        <p:nvSpPr>
-          <p:cNvPr id="4" name="">
-            <a:extLst xmlns:a="http://schemas.openxmlformats.org/drawingml/2006/main">
-              <a:ext uri="{FF2B5EF4-FFF2-40B4-BE49-F238E27FC236}">
-                <a16:creationId xmlns:a16="http://schemas.microsoft.com/office/drawing/2014/main" id="{4BCD0400-A0CD-4C59-9633-0A4ED07F4492}"/>
-              </a:ext>
-            </a:extLst>
-          </p:cNvPr>
-          <p:cNvSpPr>
-            <a:spLocks xmlns:a="http://schemas.openxmlformats.org/drawingml/2006/main" noGrp="1"/>
-          </p:cNvSpPr>
-          <p:nvPr/>
-        </p:nvSpPr>
-        <p:spPr>
-          <a:xfrm xmlns:a="http://schemas.openxmlformats.org/drawingml/2006/main">
-            <a:off x="7524750" y="1562100"/>
-            <a:ext cx="3143250" cy="876300"/>
-          </a:xfrm>
-          <a:prstGeom xmlns:a="http://schemas.openxmlformats.org/drawingml/2006/main" prst="roundRect">
-            <a:avLst>
-              <a:gd name="adj" fmla="val 13043"/>
-            </a:avLst>
-          </a:prstGeom>
-          <a:solidFill xmlns:a="http://schemas.openxmlformats.org/drawingml/2006/main">
-            <a:srgbClr val="FFFFFF"/>
-          </a:solidFill>
-          <a:ln xmlns:a="http://schemas.openxmlformats.org/drawingml/2006/main" w="9525">
-            <a:solidFill>
-              <a:srgbClr val="CBD5E1"/>
-            </a:solidFill>
-            <a:prstDash val="solid"/>
-          </a:ln>
-        </p:spPr>
-        <p:style>
-          <a:lnRef xmlns:a="http://schemas.openxmlformats.org/drawingml/2006/main" idx="0"/>
-          <a:fillRef xmlns:a="http://schemas.openxmlformats.org/drawingml/2006/main" idx="0"/>
-          <a:effectRef xmlns:a="http://schemas.openxmlformats.org/drawingml/2006/main" idx="4"/>
-          <a:fontRef xmlns:a="http://schemas.openxmlformats.org/drawingml/2006/main" idx="major"/>
-        </p:style>
-        <p:txBody xmlns:a="http://schemas.openxmlformats.org/drawingml/2006/main">
-          <a:bodyPr/>
-          <a:p/>
-        </p:txBody>
-      </p:sp>
-      <p:sp>
-        <p:nvSpPr>
-          <p:cNvPr id="5" name="">
-            <a:extLst xmlns:a="http://schemas.openxmlformats.org/drawingml/2006/main">
-              <a:ext uri="{FF2B5EF4-FFF2-40B4-BE49-F238E27FC236}">
-                <a16:creationId xmlns:a16="http://schemas.microsoft.com/office/drawing/2014/main" id="{D576515B-49E3-4778-B0CE-7C50947BA2A2}"/>
-              </a:ext>
-            </a:extLst>
-          </p:cNvPr>
-          <p:cNvSpPr>
-            <a:spLocks xmlns:a="http://schemas.openxmlformats.org/drawingml/2006/main" noGrp="1"/>
-          </p:cNvSpPr>
-          <p:nvPr/>
-        </p:nvSpPr>
-        <p:spPr>
-          <a:xfrm xmlns:a="http://schemas.openxmlformats.org/drawingml/2006/main">
-            <a:off x="7753350" y="1695450"/>
-            <a:ext cx="1238250" cy="190500"/>
+      <p:sp>
+        <p:nvSpPr>
+          <p:cNvPr id="16" name="">
+            <a:extLst xmlns:a="http://schemas.openxmlformats.org/drawingml/2006/main">
+              <a:ext uri="{FF2B5EF4-FFF2-40B4-BE49-F238E27FC236}">
+                <a16:creationId xmlns:a16="http://schemas.microsoft.com/office/drawing/2014/main" id="{AA0406E4-C808-441E-9535-37E8D841F904}"/>
+              </a:ext>
+            </a:extLst>
+          </p:cNvPr>
+          <p:cNvSpPr>
+            <a:spLocks xmlns:a="http://schemas.openxmlformats.org/drawingml/2006/main" noGrp="1"/>
+          </p:cNvSpPr>
+          <p:nvPr/>
+        </p:nvSpPr>
+        <p:spPr>
+          <a:xfrm xmlns:a="http://schemas.openxmlformats.org/drawingml/2006/main">
+            <a:off x="685800" y="6496050"/>
+            <a:ext cx="5905500" cy="171450"/>
           </a:xfrm>
           <a:prstGeom xmlns:a="http://schemas.openxmlformats.org/drawingml/2006/main" prst="rect">
             <a:avLst/>
@@ -15839,47 +13150,47 @@
           <a:lstStyle xmlns:a="http://schemas.openxmlformats.org/drawingml/2006/main"/>
           <a:p xmlns:a="http://schemas.openxmlformats.org/drawingml/2006/main">
             <a:pPr>
-              <a:defRPr sz="1050" b="1">
-                <a:solidFill>
-                  <a:srgbClr val="0F766E"/>
-                </a:solidFill>
-                <a:latin typeface="Aptos"/>
-                <a:ea typeface="Aptos"/>
-                <a:cs typeface="Aptos"/>
-              </a:defRPr>
-            </a:pPr>
-            <a:r>
-              <a:rPr sz="1050" b="1">
-                <a:solidFill>
-                  <a:srgbClr val="0F766E"/>
-                </a:solidFill>
-                <a:latin typeface="Aptos"/>
-                <a:ea typeface="Aptos"/>
-                <a:cs typeface="Aptos"/>
-              </a:rPr>
-              <a:t>mean_first10</a:t>
-            </a:r>
-          </a:p>
-        </p:txBody>
-      </p:sp>
-      <p:sp>
-        <p:nvSpPr>
-          <p:cNvPr id="6" name="">
-            <a:extLst xmlns:a="http://schemas.openxmlformats.org/drawingml/2006/main">
-              <a:ext uri="{FF2B5EF4-FFF2-40B4-BE49-F238E27FC236}">
-                <a16:creationId xmlns:a16="http://schemas.microsoft.com/office/drawing/2014/main" id="{B7C0E6D0-22D8-4B03-8F50-DF15E68BA976}"/>
-              </a:ext>
-            </a:extLst>
-          </p:cNvPr>
-          <p:cNvSpPr>
-            <a:spLocks xmlns:a="http://schemas.openxmlformats.org/drawingml/2006/main" noGrp="1"/>
-          </p:cNvSpPr>
-          <p:nvPr/>
-        </p:nvSpPr>
-        <p:spPr>
-          <a:xfrm xmlns:a="http://schemas.openxmlformats.org/drawingml/2006/main">
-            <a:off x="7753350" y="1924050"/>
-            <a:ext cx="2190750" cy="209550"/>
+              <a:defRPr sz="825">
+                <a:solidFill>
+                  <a:srgbClr val="64748B"/>
+                </a:solidFill>
+                <a:latin typeface="Aptos"/>
+                <a:ea typeface="Aptos"/>
+                <a:cs typeface="Aptos"/>
+              </a:defRPr>
+            </a:pPr>
+            <a:r>
+              <a:rPr sz="825">
+                <a:solidFill>
+                  <a:srgbClr val="64748B"/>
+                </a:solidFill>
+                <a:latin typeface="Aptos"/>
+                <a:ea typeface="Aptos"/>
+                <a:cs typeface="Aptos"/>
+              </a:rPr>
+              <a:t>Cosmos-T1 top1-top2 güven sinyali  ·  Betül Arslan</a:t>
+            </a:r>
+          </a:p>
+        </p:txBody>
+      </p:sp>
+      <p:sp>
+        <p:nvSpPr>
+          <p:cNvPr id="17" name="">
+            <a:extLst xmlns:a="http://schemas.openxmlformats.org/drawingml/2006/main">
+              <a:ext uri="{FF2B5EF4-FFF2-40B4-BE49-F238E27FC236}">
+                <a16:creationId xmlns:a16="http://schemas.microsoft.com/office/drawing/2014/main" id="{6C4C30CF-1610-4134-99C3-DD41A1E685F7}"/>
+              </a:ext>
+            </a:extLst>
+          </p:cNvPr>
+          <p:cNvSpPr>
+            <a:spLocks xmlns:a="http://schemas.openxmlformats.org/drawingml/2006/main" noGrp="1"/>
+          </p:cNvSpPr>
+          <p:nvPr/>
+        </p:nvSpPr>
+        <p:spPr>
+          <a:xfrm xmlns:a="http://schemas.openxmlformats.org/drawingml/2006/main">
+            <a:off x="11201400" y="6496050"/>
+            <a:ext cx="304800" cy="171450"/>
           </a:xfrm>
           <a:prstGeom xmlns:a="http://schemas.openxmlformats.org/drawingml/2006/main" prst="rect">
             <a:avLst/>
@@ -15894,600 +13205,6 @@
           <a:bodyPr xmlns:a="http://schemas.openxmlformats.org/drawingml/2006/main"/>
           <a:lstStyle xmlns:a="http://schemas.openxmlformats.org/drawingml/2006/main"/>
           <a:p xmlns:a="http://schemas.openxmlformats.org/drawingml/2006/main">
-            <a:pPr>
-              <a:defRPr sz="1350" b="1">
-                <a:solidFill>
-                  <a:srgbClr val="0F172A"/>
-                </a:solidFill>
-                <a:latin typeface="Aptos"/>
-                <a:ea typeface="Aptos"/>
-                <a:cs typeface="Aptos"/>
-              </a:defRPr>
-            </a:pPr>
-            <a:r>
-              <a:rPr sz="1350" b="1">
-                <a:solidFill>
-                  <a:srgbClr val="0F172A"/>
-                </a:solidFill>
-                <a:latin typeface="Aptos"/>
-                <a:ea typeface="Aptos"/>
-                <a:cs typeface="Aptos"/>
-              </a:rPr>
-              <a:t>Başlangıç güveni</a:t>
-            </a:r>
-          </a:p>
-        </p:txBody>
-      </p:sp>
-      <p:sp>
-        <p:nvSpPr>
-          <p:cNvPr id="7" name="">
-            <a:extLst xmlns:a="http://schemas.openxmlformats.org/drawingml/2006/main">
-              <a:ext uri="{FF2B5EF4-FFF2-40B4-BE49-F238E27FC236}">
-                <a16:creationId xmlns:a16="http://schemas.microsoft.com/office/drawing/2014/main" id="{5400CFF0-7AB0-4B79-81A6-A97DD03C8101}"/>
-              </a:ext>
-            </a:extLst>
-          </p:cNvPr>
-          <p:cNvSpPr>
-            <a:spLocks xmlns:a="http://schemas.openxmlformats.org/drawingml/2006/main" noGrp="1"/>
-          </p:cNvSpPr>
-          <p:nvPr/>
-        </p:nvSpPr>
-        <p:spPr>
-          <a:xfrm xmlns:a="http://schemas.openxmlformats.org/drawingml/2006/main">
-            <a:off x="7753350" y="2171700"/>
-            <a:ext cx="2571750" cy="209550"/>
-          </a:xfrm>
-          <a:prstGeom xmlns:a="http://schemas.openxmlformats.org/drawingml/2006/main" prst="rect">
-            <a:avLst/>
-          </a:prstGeom>
-          <a:noFill xmlns:a="http://schemas.openxmlformats.org/drawingml/2006/main"/>
-          <a:ln xmlns:a="http://schemas.openxmlformats.org/drawingml/2006/main" w="0">
-            <a:noFill/>
-            <a:prstDash val="solid"/>
-          </a:ln>
-        </p:spPr>
-        <p:txBody>
-          <a:bodyPr xmlns:a="http://schemas.openxmlformats.org/drawingml/2006/main"/>
-          <a:lstStyle xmlns:a="http://schemas.openxmlformats.org/drawingml/2006/main"/>
-          <a:p xmlns:a="http://schemas.openxmlformats.org/drawingml/2006/main">
-            <a:pPr>
-              <a:defRPr sz="900">
-                <a:solidFill>
-                  <a:srgbClr val="475569"/>
-                </a:solidFill>
-                <a:latin typeface="Aptos"/>
-                <a:ea typeface="Aptos"/>
-                <a:cs typeface="Aptos"/>
-              </a:defRPr>
-            </a:pPr>
-            <a:r>
-              <a:rPr sz="900">
-                <a:solidFill>
-                  <a:srgbClr val="475569"/>
-                </a:solidFill>
-                <a:latin typeface="Aptos"/>
-                <a:ea typeface="Aptos"/>
-                <a:cs typeface="Aptos"/>
-              </a:rPr>
-              <a:t>Model doğru çözüm yoluna erken giriyorsa ilk tokenlarda daha kararlı davranıyor.</a:t>
-            </a:r>
-          </a:p>
-        </p:txBody>
-      </p:sp>
-      <p:sp>
-        <p:nvSpPr>
-          <p:cNvPr id="8" name="">
-            <a:extLst xmlns:a="http://schemas.openxmlformats.org/drawingml/2006/main">
-              <a:ext uri="{FF2B5EF4-FFF2-40B4-BE49-F238E27FC236}">
-                <a16:creationId xmlns:a16="http://schemas.microsoft.com/office/drawing/2014/main" id="{C8B1CB32-58AF-4489-BCFA-E3491AFFE1C2}"/>
-              </a:ext>
-            </a:extLst>
-          </p:cNvPr>
-          <p:cNvSpPr>
-            <a:spLocks xmlns:a="http://schemas.openxmlformats.org/drawingml/2006/main" noGrp="1"/>
-          </p:cNvSpPr>
-          <p:nvPr/>
-        </p:nvSpPr>
-        <p:spPr>
-          <a:xfrm xmlns:a="http://schemas.openxmlformats.org/drawingml/2006/main">
-            <a:off x="7524750" y="2686050"/>
-            <a:ext cx="3143250" cy="876300"/>
-          </a:xfrm>
-          <a:prstGeom xmlns:a="http://schemas.openxmlformats.org/drawingml/2006/main" prst="roundRect">
-            <a:avLst>
-              <a:gd name="adj" fmla="val 13043"/>
-            </a:avLst>
-          </a:prstGeom>
-          <a:solidFill xmlns:a="http://schemas.openxmlformats.org/drawingml/2006/main">
-            <a:srgbClr val="FFFFFF"/>
-          </a:solidFill>
-          <a:ln xmlns:a="http://schemas.openxmlformats.org/drawingml/2006/main" w="9525">
-            <a:solidFill>
-              <a:srgbClr val="CBD5E1"/>
-            </a:solidFill>
-            <a:prstDash val="solid"/>
-          </a:ln>
-        </p:spPr>
-        <p:style>
-          <a:lnRef xmlns:a="http://schemas.openxmlformats.org/drawingml/2006/main" idx="0"/>
-          <a:fillRef xmlns:a="http://schemas.openxmlformats.org/drawingml/2006/main" idx="0"/>
-          <a:effectRef xmlns:a="http://schemas.openxmlformats.org/drawingml/2006/main" idx="4"/>
-          <a:fontRef xmlns:a="http://schemas.openxmlformats.org/drawingml/2006/main" idx="major"/>
-        </p:style>
-        <p:txBody xmlns:a="http://schemas.openxmlformats.org/drawingml/2006/main">
-          <a:bodyPr/>
-          <a:p/>
-        </p:txBody>
-      </p:sp>
-      <p:sp>
-        <p:nvSpPr>
-          <p:cNvPr id="9" name="">
-            <a:extLst xmlns:a="http://schemas.openxmlformats.org/drawingml/2006/main">
-              <a:ext uri="{FF2B5EF4-FFF2-40B4-BE49-F238E27FC236}">
-                <a16:creationId xmlns:a16="http://schemas.microsoft.com/office/drawing/2014/main" id="{57C9B9DC-9E6E-42BE-B59F-71C87B4B8ED0}"/>
-              </a:ext>
-            </a:extLst>
-          </p:cNvPr>
-          <p:cNvSpPr>
-            <a:spLocks xmlns:a="http://schemas.openxmlformats.org/drawingml/2006/main" noGrp="1"/>
-          </p:cNvSpPr>
-          <p:nvPr/>
-        </p:nvSpPr>
-        <p:spPr>
-          <a:xfrm xmlns:a="http://schemas.openxmlformats.org/drawingml/2006/main">
-            <a:off x="7753350" y="2819400"/>
-            <a:ext cx="1238250" cy="190500"/>
-          </a:xfrm>
-          <a:prstGeom xmlns:a="http://schemas.openxmlformats.org/drawingml/2006/main" prst="rect">
-            <a:avLst/>
-          </a:prstGeom>
-          <a:noFill xmlns:a="http://schemas.openxmlformats.org/drawingml/2006/main"/>
-          <a:ln xmlns:a="http://schemas.openxmlformats.org/drawingml/2006/main" w="0">
-            <a:noFill/>
-            <a:prstDash val="solid"/>
-          </a:ln>
-        </p:spPr>
-        <p:txBody>
-          <a:bodyPr xmlns:a="http://schemas.openxmlformats.org/drawingml/2006/main"/>
-          <a:lstStyle xmlns:a="http://schemas.openxmlformats.org/drawingml/2006/main"/>
-          <a:p xmlns:a="http://schemas.openxmlformats.org/drawingml/2006/main">
-            <a:pPr>
-              <a:defRPr sz="1050" b="1">
-                <a:solidFill>
-                  <a:srgbClr val="0F766E"/>
-                </a:solidFill>
-                <a:latin typeface="Aptos"/>
-                <a:ea typeface="Aptos"/>
-                <a:cs typeface="Aptos"/>
-              </a:defRPr>
-            </a:pPr>
-            <a:r>
-              <a:rPr sz="1050" b="1">
-                <a:solidFill>
-                  <a:srgbClr val="0F766E"/>
-                </a:solidFill>
-                <a:latin typeface="Aptos"/>
-                <a:ea typeface="Aptos"/>
-                <a:cs typeface="Aptos"/>
-              </a:rPr>
-              <a:t>mean_last10</a:t>
-            </a:r>
-          </a:p>
-        </p:txBody>
-      </p:sp>
-      <p:sp>
-        <p:nvSpPr>
-          <p:cNvPr id="10" name="">
-            <a:extLst xmlns:a="http://schemas.openxmlformats.org/drawingml/2006/main">
-              <a:ext uri="{FF2B5EF4-FFF2-40B4-BE49-F238E27FC236}">
-                <a16:creationId xmlns:a16="http://schemas.microsoft.com/office/drawing/2014/main" id="{49800FA7-0F6D-4FF8-AB7E-C44D28F6D367}"/>
-              </a:ext>
-            </a:extLst>
-          </p:cNvPr>
-          <p:cNvSpPr>
-            <a:spLocks xmlns:a="http://schemas.openxmlformats.org/drawingml/2006/main" noGrp="1"/>
-          </p:cNvSpPr>
-          <p:nvPr/>
-        </p:nvSpPr>
-        <p:spPr>
-          <a:xfrm xmlns:a="http://schemas.openxmlformats.org/drawingml/2006/main">
-            <a:off x="7753350" y="3048000"/>
-            <a:ext cx="2190750" cy="209550"/>
-          </a:xfrm>
-          <a:prstGeom xmlns:a="http://schemas.openxmlformats.org/drawingml/2006/main" prst="rect">
-            <a:avLst/>
-          </a:prstGeom>
-          <a:noFill xmlns:a="http://schemas.openxmlformats.org/drawingml/2006/main"/>
-          <a:ln xmlns:a="http://schemas.openxmlformats.org/drawingml/2006/main" w="0">
-            <a:noFill/>
-            <a:prstDash val="solid"/>
-          </a:ln>
-        </p:spPr>
-        <p:txBody>
-          <a:bodyPr xmlns:a="http://schemas.openxmlformats.org/drawingml/2006/main"/>
-          <a:lstStyle xmlns:a="http://schemas.openxmlformats.org/drawingml/2006/main"/>
-          <a:p xmlns:a="http://schemas.openxmlformats.org/drawingml/2006/main">
-            <a:pPr>
-              <a:defRPr sz="1350" b="1">
-                <a:solidFill>
-                  <a:srgbClr val="0F172A"/>
-                </a:solidFill>
-                <a:latin typeface="Aptos"/>
-                <a:ea typeface="Aptos"/>
-                <a:cs typeface="Aptos"/>
-              </a:defRPr>
-            </a:pPr>
-            <a:r>
-              <a:rPr sz="1350" b="1">
-                <a:solidFill>
-                  <a:srgbClr val="0F172A"/>
-                </a:solidFill>
-                <a:latin typeface="Aptos"/>
-                <a:ea typeface="Aptos"/>
-                <a:cs typeface="Aptos"/>
-              </a:rPr>
-              <a:t>Son bölüm güveni</a:t>
-            </a:r>
-          </a:p>
-        </p:txBody>
-      </p:sp>
-      <p:sp>
-        <p:nvSpPr>
-          <p:cNvPr id="11" name="">
-            <a:extLst xmlns:a="http://schemas.openxmlformats.org/drawingml/2006/main">
-              <a:ext uri="{FF2B5EF4-FFF2-40B4-BE49-F238E27FC236}">
-                <a16:creationId xmlns:a16="http://schemas.microsoft.com/office/drawing/2014/main" id="{EBB38613-A9DB-4B56-A12A-8D600140B4B0}"/>
-              </a:ext>
-            </a:extLst>
-          </p:cNvPr>
-          <p:cNvSpPr>
-            <a:spLocks xmlns:a="http://schemas.openxmlformats.org/drawingml/2006/main" noGrp="1"/>
-          </p:cNvSpPr>
-          <p:nvPr/>
-        </p:nvSpPr>
-        <p:spPr>
-          <a:xfrm xmlns:a="http://schemas.openxmlformats.org/drawingml/2006/main">
-            <a:off x="7753350" y="3295650"/>
-            <a:ext cx="2571750" cy="209550"/>
-          </a:xfrm>
-          <a:prstGeom xmlns:a="http://schemas.openxmlformats.org/drawingml/2006/main" prst="rect">
-            <a:avLst/>
-          </a:prstGeom>
-          <a:noFill xmlns:a="http://schemas.openxmlformats.org/drawingml/2006/main"/>
-          <a:ln xmlns:a="http://schemas.openxmlformats.org/drawingml/2006/main" w="0">
-            <a:noFill/>
-            <a:prstDash val="solid"/>
-          </a:ln>
-        </p:spPr>
-        <p:txBody>
-          <a:bodyPr xmlns:a="http://schemas.openxmlformats.org/drawingml/2006/main"/>
-          <a:lstStyle xmlns:a="http://schemas.openxmlformats.org/drawingml/2006/main"/>
-          <a:p xmlns:a="http://schemas.openxmlformats.org/drawingml/2006/main">
-            <a:pPr>
-              <a:defRPr sz="900">
-                <a:solidFill>
-                  <a:srgbClr val="475569"/>
-                </a:solidFill>
-                <a:latin typeface="Aptos"/>
-                <a:ea typeface="Aptos"/>
-                <a:cs typeface="Aptos"/>
-              </a:defRPr>
-            </a:pPr>
-            <a:r>
-              <a:rPr sz="900">
-                <a:solidFill>
-                  <a:srgbClr val="475569"/>
-                </a:solidFill>
-                <a:latin typeface="Aptos"/>
-                <a:ea typeface="Aptos"/>
-                <a:cs typeface="Aptos"/>
-              </a:rPr>
-              <a:t>Nihai cevap yaklaştıkça güven profili doğru/yanlış ayrımında etkili oluyor.</a:t>
-            </a:r>
-          </a:p>
-        </p:txBody>
-      </p:sp>
-      <p:sp>
-        <p:nvSpPr>
-          <p:cNvPr id="12" name="">
-            <a:extLst xmlns:a="http://schemas.openxmlformats.org/drawingml/2006/main">
-              <a:ext uri="{FF2B5EF4-FFF2-40B4-BE49-F238E27FC236}">
-                <a16:creationId xmlns:a16="http://schemas.microsoft.com/office/drawing/2014/main" id="{14C6EEBF-9259-4EED-9624-73B5B5919052}"/>
-              </a:ext>
-            </a:extLst>
-          </p:cNvPr>
-          <p:cNvSpPr>
-            <a:spLocks xmlns:a="http://schemas.openxmlformats.org/drawingml/2006/main" noGrp="1"/>
-          </p:cNvSpPr>
-          <p:nvPr/>
-        </p:nvSpPr>
-        <p:spPr>
-          <a:xfrm xmlns:a="http://schemas.openxmlformats.org/drawingml/2006/main">
-            <a:off x="7524750" y="3810000"/>
-            <a:ext cx="3143250" cy="876300"/>
-          </a:xfrm>
-          <a:prstGeom xmlns:a="http://schemas.openxmlformats.org/drawingml/2006/main" prst="roundRect">
-            <a:avLst>
-              <a:gd name="adj" fmla="val 13043"/>
-            </a:avLst>
-          </a:prstGeom>
-          <a:solidFill xmlns:a="http://schemas.openxmlformats.org/drawingml/2006/main">
-            <a:srgbClr val="FFFFFF"/>
-          </a:solidFill>
-          <a:ln xmlns:a="http://schemas.openxmlformats.org/drawingml/2006/main" w="9525">
-            <a:solidFill>
-              <a:srgbClr val="CBD5E1"/>
-            </a:solidFill>
-            <a:prstDash val="solid"/>
-          </a:ln>
-        </p:spPr>
-        <p:style>
-          <a:lnRef xmlns:a="http://schemas.openxmlformats.org/drawingml/2006/main" idx="0"/>
-          <a:fillRef xmlns:a="http://schemas.openxmlformats.org/drawingml/2006/main" idx="0"/>
-          <a:effectRef xmlns:a="http://schemas.openxmlformats.org/drawingml/2006/main" idx="4"/>
-          <a:fontRef xmlns:a="http://schemas.openxmlformats.org/drawingml/2006/main" idx="major"/>
-        </p:style>
-        <p:txBody xmlns:a="http://schemas.openxmlformats.org/drawingml/2006/main">
-          <a:bodyPr/>
-          <a:p/>
-        </p:txBody>
-      </p:sp>
-      <p:sp>
-        <p:nvSpPr>
-          <p:cNvPr id="13" name="">
-            <a:extLst xmlns:a="http://schemas.openxmlformats.org/drawingml/2006/main">
-              <a:ext uri="{FF2B5EF4-FFF2-40B4-BE49-F238E27FC236}">
-                <a16:creationId xmlns:a16="http://schemas.microsoft.com/office/drawing/2014/main" id="{418CB97B-957B-4A23-A63E-F31F683C7769}"/>
-              </a:ext>
-            </a:extLst>
-          </p:cNvPr>
-          <p:cNvSpPr>
-            <a:spLocks xmlns:a="http://schemas.openxmlformats.org/drawingml/2006/main" noGrp="1"/>
-          </p:cNvSpPr>
-          <p:nvPr/>
-        </p:nvSpPr>
-        <p:spPr>
-          <a:xfrm xmlns:a="http://schemas.openxmlformats.org/drawingml/2006/main">
-            <a:off x="7753350" y="3943350"/>
-            <a:ext cx="1238250" cy="190500"/>
-          </a:xfrm>
-          <a:prstGeom xmlns:a="http://schemas.openxmlformats.org/drawingml/2006/main" prst="rect">
-            <a:avLst/>
-          </a:prstGeom>
-          <a:noFill xmlns:a="http://schemas.openxmlformats.org/drawingml/2006/main"/>
-          <a:ln xmlns:a="http://schemas.openxmlformats.org/drawingml/2006/main" w="0">
-            <a:noFill/>
-            <a:prstDash val="solid"/>
-          </a:ln>
-        </p:spPr>
-        <p:txBody>
-          <a:bodyPr xmlns:a="http://schemas.openxmlformats.org/drawingml/2006/main"/>
-          <a:lstStyle xmlns:a="http://schemas.openxmlformats.org/drawingml/2006/main"/>
-          <a:p xmlns:a="http://schemas.openxmlformats.org/drawingml/2006/main">
-            <a:pPr>
-              <a:defRPr sz="1050" b="1">
-                <a:solidFill>
-                  <a:srgbClr val="0F766E"/>
-                </a:solidFill>
-                <a:latin typeface="Aptos"/>
-                <a:ea typeface="Aptos"/>
-                <a:cs typeface="Aptos"/>
-              </a:defRPr>
-            </a:pPr>
-            <a:r>
-              <a:rPr sz="1050" b="1">
-                <a:solidFill>
-                  <a:srgbClr val="0F766E"/>
-                </a:solidFill>
-                <a:latin typeface="Aptos"/>
-                <a:ea typeface="Aptos"/>
-                <a:cs typeface="Aptos"/>
-              </a:rPr>
-              <a:t>q115</a:t>
-            </a:r>
-          </a:p>
-        </p:txBody>
-      </p:sp>
-      <p:sp>
-        <p:nvSpPr>
-          <p:cNvPr id="14" name="">
-            <a:extLst xmlns:a="http://schemas.openxmlformats.org/drawingml/2006/main">
-              <a:ext uri="{FF2B5EF4-FFF2-40B4-BE49-F238E27FC236}">
-                <a16:creationId xmlns:a16="http://schemas.microsoft.com/office/drawing/2014/main" id="{03EBF259-CC18-4D49-8270-AC45C1A90238}"/>
-              </a:ext>
-            </a:extLst>
-          </p:cNvPr>
-          <p:cNvSpPr>
-            <a:spLocks xmlns:a="http://schemas.openxmlformats.org/drawingml/2006/main" noGrp="1"/>
-          </p:cNvSpPr>
-          <p:nvPr/>
-        </p:nvSpPr>
-        <p:spPr>
-          <a:xfrm xmlns:a="http://schemas.openxmlformats.org/drawingml/2006/main">
-            <a:off x="7753350" y="4171950"/>
-            <a:ext cx="2190750" cy="209550"/>
-          </a:xfrm>
-          <a:prstGeom xmlns:a="http://schemas.openxmlformats.org/drawingml/2006/main" prst="rect">
-            <a:avLst/>
-          </a:prstGeom>
-          <a:noFill xmlns:a="http://schemas.openxmlformats.org/drawingml/2006/main"/>
-          <a:ln xmlns:a="http://schemas.openxmlformats.org/drawingml/2006/main" w="0">
-            <a:noFill/>
-            <a:prstDash val="solid"/>
-          </a:ln>
-        </p:spPr>
-        <p:txBody>
-          <a:bodyPr xmlns:a="http://schemas.openxmlformats.org/drawingml/2006/main"/>
-          <a:lstStyle xmlns:a="http://schemas.openxmlformats.org/drawingml/2006/main"/>
-          <a:p xmlns:a="http://schemas.openxmlformats.org/drawingml/2006/main">
-            <a:pPr>
-              <a:defRPr sz="1350" b="1">
-                <a:solidFill>
-                  <a:srgbClr val="0F172A"/>
-                </a:solidFill>
-                <a:latin typeface="Aptos"/>
-                <a:ea typeface="Aptos"/>
-                <a:cs typeface="Aptos"/>
-              </a:defRPr>
-            </a:pPr>
-            <a:r>
-              <a:rPr sz="1350" b="1">
-                <a:solidFill>
-                  <a:srgbClr val="0F172A"/>
-                </a:solidFill>
-                <a:latin typeface="Aptos"/>
-                <a:ea typeface="Aptos"/>
-                <a:cs typeface="Aptos"/>
-              </a:rPr>
-              <a:t>Üst güven bandı</a:t>
-            </a:r>
-          </a:p>
-        </p:txBody>
-      </p:sp>
-      <p:sp>
-        <p:nvSpPr>
-          <p:cNvPr id="15" name="">
-            <a:extLst xmlns:a="http://schemas.openxmlformats.org/drawingml/2006/main">
-              <a:ext uri="{FF2B5EF4-FFF2-40B4-BE49-F238E27FC236}">
-                <a16:creationId xmlns:a16="http://schemas.microsoft.com/office/drawing/2014/main" id="{3F9E1FFE-B2AD-4E82-AB59-CF3A512B4377}"/>
-              </a:ext>
-            </a:extLst>
-          </p:cNvPr>
-          <p:cNvSpPr>
-            <a:spLocks xmlns:a="http://schemas.openxmlformats.org/drawingml/2006/main" noGrp="1"/>
-          </p:cNvSpPr>
-          <p:nvPr/>
-        </p:nvSpPr>
-        <p:spPr>
-          <a:xfrm xmlns:a="http://schemas.openxmlformats.org/drawingml/2006/main">
-            <a:off x="7753350" y="4419600"/>
-            <a:ext cx="2571750" cy="209550"/>
-          </a:xfrm>
-          <a:prstGeom xmlns:a="http://schemas.openxmlformats.org/drawingml/2006/main" prst="rect">
-            <a:avLst/>
-          </a:prstGeom>
-          <a:noFill xmlns:a="http://schemas.openxmlformats.org/drawingml/2006/main"/>
-          <a:ln xmlns:a="http://schemas.openxmlformats.org/drawingml/2006/main" w="0">
-            <a:noFill/>
-            <a:prstDash val="solid"/>
-          </a:ln>
-        </p:spPr>
-        <p:txBody>
-          <a:bodyPr xmlns:a="http://schemas.openxmlformats.org/drawingml/2006/main"/>
-          <a:lstStyle xmlns:a="http://schemas.openxmlformats.org/drawingml/2006/main"/>
-          <a:p xmlns:a="http://schemas.openxmlformats.org/drawingml/2006/main">
-            <a:pPr>
-              <a:defRPr sz="900">
-                <a:solidFill>
-                  <a:srgbClr val="475569"/>
-                </a:solidFill>
-                <a:latin typeface="Aptos"/>
-                <a:ea typeface="Aptos"/>
-                <a:cs typeface="Aptos"/>
-              </a:defRPr>
-            </a:pPr>
-            <a:r>
-              <a:rPr sz="900">
-                <a:solidFill>
-                  <a:srgbClr val="475569"/>
-                </a:solidFill>
-                <a:latin typeface="Aptos"/>
-                <a:ea typeface="Aptos"/>
-                <a:cs typeface="Aptos"/>
-              </a:rPr>
-              <a:t>Dağılımın yüksek güven bölgesi doğru cevaplarla daha tutarlı görünüyor.</a:t>
-            </a:r>
-          </a:p>
-        </p:txBody>
-      </p:sp>
-      <p:sp>
-        <p:nvSpPr>
-          <p:cNvPr id="16" name="">
-            <a:extLst xmlns:a="http://schemas.openxmlformats.org/drawingml/2006/main">
-              <a:ext uri="{FF2B5EF4-FFF2-40B4-BE49-F238E27FC236}">
-                <a16:creationId xmlns:a16="http://schemas.microsoft.com/office/drawing/2014/main" id="{AA0406E4-C808-441E-9535-37E8D841F904}"/>
-              </a:ext>
-            </a:extLst>
-          </p:cNvPr>
-          <p:cNvSpPr>
-            <a:spLocks xmlns:a="http://schemas.openxmlformats.org/drawingml/2006/main" noGrp="1"/>
-          </p:cNvSpPr>
-          <p:nvPr/>
-        </p:nvSpPr>
-        <p:spPr>
-          <a:xfrm xmlns:a="http://schemas.openxmlformats.org/drawingml/2006/main">
-            <a:off x="685800" y="6496050"/>
-            <a:ext cx="5905500" cy="171450"/>
-          </a:xfrm>
-          <a:prstGeom xmlns:a="http://schemas.openxmlformats.org/drawingml/2006/main" prst="rect">
-            <a:avLst/>
-          </a:prstGeom>
-          <a:noFill xmlns:a="http://schemas.openxmlformats.org/drawingml/2006/main"/>
-          <a:ln xmlns:a="http://schemas.openxmlformats.org/drawingml/2006/main" w="0">
-            <a:noFill/>
-            <a:prstDash val="solid"/>
-          </a:ln>
-        </p:spPr>
-        <p:txBody>
-          <a:bodyPr xmlns:a="http://schemas.openxmlformats.org/drawingml/2006/main"/>
-          <a:lstStyle xmlns:a="http://schemas.openxmlformats.org/drawingml/2006/main"/>
-          <a:p xmlns:a="http://schemas.openxmlformats.org/drawingml/2006/main">
-            <a:pPr>
-              <a:defRPr sz="825">
-                <a:solidFill>
-                  <a:srgbClr val="64748B"/>
-                </a:solidFill>
-                <a:latin typeface="Aptos"/>
-                <a:ea typeface="Aptos"/>
-                <a:cs typeface="Aptos"/>
-              </a:defRPr>
-            </a:pPr>
-            <a:r>
-              <a:rPr sz="825">
-                <a:solidFill>
-                  <a:srgbClr val="64748B"/>
-                </a:solidFill>
-                <a:latin typeface="Aptos"/>
-                <a:ea typeface="Aptos"/>
-                <a:cs typeface="Aptos"/>
-              </a:rPr>
-              <a:t>Cosmos-T1 top1-top2 güven sinyali  ·  Betül Arslan</a:t>
-            </a:r>
-          </a:p>
-        </p:txBody>
-      </p:sp>
-      <p:sp>
-        <p:nvSpPr>
-          <p:cNvPr id="17" name="">
-            <a:extLst xmlns:a="http://schemas.openxmlformats.org/drawingml/2006/main">
-              <a:ext uri="{FF2B5EF4-FFF2-40B4-BE49-F238E27FC236}">
-                <a16:creationId xmlns:a16="http://schemas.microsoft.com/office/drawing/2014/main" id="{6C4C30CF-1610-4134-99C3-DD41A1E685F7}"/>
-              </a:ext>
-            </a:extLst>
-          </p:cNvPr>
-          <p:cNvSpPr>
-            <a:spLocks xmlns:a="http://schemas.openxmlformats.org/drawingml/2006/main" noGrp="1"/>
-          </p:cNvSpPr>
-          <p:nvPr/>
-        </p:nvSpPr>
-        <p:spPr>
-          <a:xfrm xmlns:a="http://schemas.openxmlformats.org/drawingml/2006/main">
-            <a:off x="11201400" y="6496050"/>
-            <a:ext cx="304800" cy="171450"/>
-          </a:xfrm>
-          <a:prstGeom xmlns:a="http://schemas.openxmlformats.org/drawingml/2006/main" prst="rect">
-            <a:avLst/>
-          </a:prstGeom>
-          <a:noFill xmlns:a="http://schemas.openxmlformats.org/drawingml/2006/main"/>
-          <a:ln xmlns:a="http://schemas.openxmlformats.org/drawingml/2006/main" w="0">
-            <a:noFill/>
-            <a:prstDash val="solid"/>
-          </a:ln>
-        </p:spPr>
-        <p:txBody>
-          <a:bodyPr xmlns:a="http://schemas.openxmlformats.org/drawingml/2006/main"/>
-          <a:lstStyle xmlns:a="http://schemas.openxmlformats.org/drawingml/2006/main"/>
-          <a:p xmlns:a="http://schemas.openxmlformats.org/drawingml/2006/main">
             <a:pPr algn="r">
               <a:defRPr sz="825" b="1">
                 <a:solidFill>
@@ -16507,14 +13224,14 @@
                 <a:ea typeface="Aptos"/>
                 <a:cs typeface="Aptos"/>
               </a:rPr>
-              <a:t>014</a:t>
+              <a:t>09</a:t>
             </a:r>
           </a:p>
         </p:txBody>
       </p:sp>
       <p:pic xmlns:a="http://schemas.openxmlformats.org/drawingml/2006/main" xmlns:r="http://schemas.openxmlformats.org/officeDocument/2006/relationships">
         <p:nvPicPr>
-          <p:cNvPr id="21" name="Picture 20" descr="fig_feat_imp.png"/>
+          <p:cNvPr id="18" name="Picture 17" descr="fig_feat_imp.png"/>
           <p:cNvPicPr>
             <a:picLocks noChangeAspect="1"/>
           </p:cNvPicPr>
@@ -16528,8 +13245,8 @@
         </p:blipFill>
         <p:spPr>
           <a:xfrm>
-            <a:off x="274320" y="1920240"/>
-            <a:ext cx="8595360" cy="3032200"/>
+            <a:off x="274320" y="1463040"/>
+            <a:ext cx="11612880" cy="4096696"/>
           </a:xfrm>
           <a:prstGeom prst="rect">
             <a:avLst/>

</xml_diff>